<commit_message>
Informe y presentación v2 con resultados E.030 (Random Forest; Gradient Boosting como comparación)
- resumen_e030.py: entrena RF_normalizado con la partición del repositorio de Jean Piere
  (1 200/300 por familia) y lo evalúa una vez en las 300 familias reservadas:
  deriva R² 0,990, MAE 0,040 %, 137 de 146 excedencias (GB: 0,995, 139 de 146)
- Informe v2 (5 págs.): metodología E.030 actualizada, sección 3.2 nueva, discusión y conclusiones
- Presentación v2 (15 diap.): diapositiva E.030, cifras de 1 500 estructuras, tema aplicado sin apply_theme.js
- PDF exportados con Word y PowerPoint; notas del vault actualizadas

Co-Authored-By: Claude Opus 5.5 <noreply@anthropic.com>
</commit_message>
<xml_diff>
--- a/04 Entregables/Presentacion/Presentacion_Nexo_Sismico.pptx
+++ b/04 Entregables/Presentacion/Presentacion_Nexo_Sismico.pptx
@@ -19,9 +19,10 @@
     <p:sldId id="267" r:id="rId13"/>
     <p:sldId id="268" r:id="rId14"/>
     <p:sldId id="269" r:id="rId15"/>
+    <p:sldId id="270" r:id="rId16"/>
   </p:sldIdLst>
   <p:notesMasterIdLst>
-    <p:notesMasterId r:id="rId16"/>
+    <p:notesMasterId r:id="rId17"/>
   </p:notesMasterIdLst>
   <p:sldSz cx="9144000" cy="5143500"/>
   <p:notesSz cx="5143500" cy="9144000"/>
@@ -120,42 +121,43 @@
   <p:extLst>
     <p:ext uri="{521415D9-36F7-43E2-AB2F-B90AF26B5E84}">
       <p14:sectionLst xmlns:p14="http://schemas.microsoft.com/office/powerpoint/2010/main">
-        <p14:section name="Apertura" id="{9be78039-5a5a-cab1-9f49-47540ccd79c2}">
+        <p14:section name="Apertura" id="{139e17a4-174b-be7e-6245-bc236eaa436a}">
           <p14:sldIdLst>
             <p14:sldId id="256"/>
           </p14:sldIdLst>
         </p14:section>
-        <p14:section name="Problema y pregunta" id="{b83c2a6c-980a-676d-3c4c-813637c443ae}">
+        <p14:section name="Problema y pregunta" id="{965b17fe-4a8f-cb17-ac34-ba2439b139f8}">
           <p14:sldIdLst>
             <p14:sldId id="257"/>
             <p14:sldId id="258"/>
           </p14:sldIdLst>
         </p14:section>
-        <p14:section name="Solución" id="{cbbd35eb-e312-e2b5-1339-37bca940aa94}">
+        <p14:section name="Solución" id="{c2a8df56-fefc-9bd5-da54-78b9ec223bec}">
           <p14:sldIdLst>
             <p14:sldId id="259"/>
             <p14:sldId id="260"/>
           </p14:sldIdLst>
         </p14:section>
-        <p14:section name="Prototipo" id="{9b474036-9edf-a9d5-3249-8256aa737b7a}">
+        <p14:section name="Prototipo" id="{4d273800-01bd-e3c8-69ba-0010788d9167}">
           <p14:sldIdLst>
             <p14:sldId id="261"/>
             <p14:sldId id="262"/>
             <p14:sldId id="263"/>
           </p14:sldIdLst>
         </p14:section>
-        <p14:section name="Resultados" id="{bd2f325c-2dc3-2105-1df7-7c4bb75c4264}">
+        <p14:section name="Resultados" id="{37c8bf5d-4991-535d-4089-e3c9028de20c}">
           <p14:sldIdLst>
             <p14:sldId id="264"/>
             <p14:sldId id="265"/>
             <p14:sldId id="266"/>
+            <p14:sldId id="267"/>
           </p14:sldIdLst>
         </p14:section>
-        <p14:section name="Cierre" id="{7ebb9ebb-6f2b-d517-4129-af9c9ba4a019}">
+        <p14:section name="Cierre" id="{d0bac045-934d-263e-7996-20402bdb3b49}">
           <p14:sldIdLst>
-            <p14:sldId id="267"/>
             <p14:sldId id="268"/>
             <p14:sldId id="269"/>
+            <p14:sldId id="270"/>
           </p14:sldIdLst>
         </p14:section>
       </p14:sectionLst>
@@ -1011,7 +1013,7 @@
           <a:p>
             <a:r>
               <a:rPr lang="en-US" dirty="0"/>
-              <a:t>Evaluamos Random Forest dejando cada planta completa por fuera. Con plantas que nunca vio, su error en la deriva fue de 0,086 puntos en X y 0,101 en Y: un 39 % menos que predecir la media y mejor que la regresión lineal. Cada predicción toma unos 32 milisegundos.</a:t>
+              <a:t>Para la ruta NSR-10 armamos una base con 18 edificios que diseñó el profesor Rojas Vallejo con su algoritmo en OpenSees, más el caso del curso. El profesor nos advirtió que varios son teóricos y que las plantas que faltan fallaron en el dimensionamiento. Los usamos para entrenar y comparar, no como diseños.</a:t>
             </a:r>
             <a:endParaRPr lang="en-US" dirty="0"/>
           </a:p>
@@ -1099,7 +1101,7 @@
           <a:p>
             <a:r>
               <a:rPr lang="en-US" dirty="0"/>
-              <a:t>Pero hay que ser honestos: de siete edificios cerca del límite, el modelo detectó tres y subestimó cuatro. No dio falsas alarmas. Por eso hoy sirve para ordenar alternativas, y la verificación final sigue en el módulo NSR-10 y SAP2000.</a:t>
+              <a:t>Evaluamos Random Forest dejando cada planta completa por fuera. Con plantas que nunca vio, su error en la deriva fue de 0,086 puntos en X y 0,101 en Y: un 39 % menos que predecir la media y mejor que la regresión lineal. Cada predicción toma unos 32 milisegundos.</a:t>
             </a:r>
             <a:endParaRPr lang="en-US" dirty="0"/>
           </a:p>
@@ -1187,7 +1189,7 @@
           <a:p>
             <a:r>
               <a:rPr lang="en-US" dirty="0"/>
-              <a:t>Las limitaciones: la base NSR-10 es pequeña y teórica; las métricas del Random Forest en la ruta E.030 están pendientes; no cronometramos el flujo completo en SAP2000, así que no afirmamos un porcentaje de ahorro; y el bot todavía no está conectado al predictor.</a:t>
+              <a:t>Pero hay que ser honestos: de siete edificios cerca del límite, el modelo detectó tres y subestimó cuatro. No dio falsas alarmas. Con 18 datos sirve para ordenar alternativas; con 1 500, como en la ruta E.030, la precisión sube de forma drástica. La lección es que ampliar la base colombiana con casos verificados es el siguiente paso.</a:t>
             </a:r>
             <a:endParaRPr lang="en-US" dirty="0"/>
           </a:p>
@@ -1275,7 +1277,7 @@
           <a:p>
             <a:r>
               <a:rPr lang="en-US" dirty="0"/>
-              <a:t>En conclusión: el módulo NSR-10 reproduce el cálculo de referencia y filtra datos malos; el Random Forest reduce el error un 39 % en plantas que no vio, pero todavía no detecta todos los casos al límite. Los siguientes pasos son evaluar la ruta E.030, ampliar la base con casos verificados, conectar todo al bot y medir el ahorro de tiempo real.</a:t>
+              <a:t>Las limitaciones: la base NSR-10 es pequeña y teórica; el modelo E.030 solo vale de 2 a 5 pisos y con sus hipótesis de rigidez; no cronometramos el flujo completo en SAP2000, así que no afirmamos un porcentaje de ahorro; y el bot todavía no está conectado al predictor.</a:t>
             </a:r>
             <a:endParaRPr lang="en-US" dirty="0"/>
           </a:p>
@@ -1363,7 +1365,7 @@
           <a:p>
             <a:r>
               <a:rPr lang="en-US" dirty="0"/>
-              <a:t>Somos cinco: Lucero en el planteamiento, Alexis en la generación y OpenSees, Nicolás en el módulo NSR-10, Jean Piere en datos, Random Forest y el bot, y Joseph en validación y coordinación. Agradecemos al profesor Thomas Rojas Vallejo por sus datos. Gracias.</a:t>
+              <a:t>En conclusión: el módulo NSR-10 reproduce el cálculo de referencia y filtra datos malos; con 1 500 edificios Random Forest estima la deriva de familias nuevas con R² de 0,99 y detecta casi todas las excedencias; con 18 edificios colombianos solo sirve para priorizar. Los siguientes pasos son ampliar la base NSR-10 con casos verificados, conectar todo al bot y medir el ahorro de tiempo real.</a:t>
             </a:r>
             <a:endParaRPr lang="en-US" dirty="0"/>
           </a:p>
@@ -1387,6 +1389,94 @@
             <a:fld id="{F7021451-1387-4CA6-816F-3879F97B5CBC}" type="slidenum">
               <a:rPr lang="en-US"/>
               <a:t>14</a:t>
+            </a:fld>
+            <a:endParaRPr lang="en-US"/>
+          </a:p>
+        </p:txBody>
+      </p:sp>
+    </p:spTree>
+    <p:extLst>
+      <p:ext uri="{BB962C8B-B14F-4D97-AF65-F5344CB8AC3E}">
+        <p14:creationId xmlns:p14="http://schemas.microsoft.com/office/powerpoint/2010/main" val="1024086991"/>
+      </p:ext>
+    </p:extLst>
+  </p:cSld>
+  <p:clrMapOvr>
+    <a:masterClrMapping/>
+  </p:clrMapOvr>
+</p:notes>
+</file>
+
+<file path=ppt/notesSlides/notesSlide15.xml><?xml version="1.0" encoding="utf-8"?>
+<p:notes xmlns:a="http://schemas.openxmlformats.org/drawingml/2006/main" xmlns:r="http://schemas.openxmlformats.org/officeDocument/2006/relationships" xmlns:p="http://schemas.openxmlformats.org/presentationml/2006/main">
+  <p:cSld>
+    <p:spTree>
+      <p:nvGrpSpPr>
+        <p:cNvPr id="1" name=""/>
+        <p:cNvGrpSpPr/>
+        <p:nvPr/>
+      </p:nvGrpSpPr>
+      <p:grpSpPr>
+        <a:xfrm>
+          <a:off x="0" y="0"/>
+          <a:ext cx="0" cy="0"/>
+          <a:chOff x="0" y="0"/>
+          <a:chExt cx="0" cy="0"/>
+        </a:xfrm>
+      </p:grpSpPr>
+      <p:sp>
+        <p:nvSpPr>
+          <p:cNvPr id="2" name="Slide Image Placeholder 1"/>
+          <p:cNvSpPr>
+            <a:spLocks noGrp="1" noRot="1" noChangeAspect="1"/>
+          </p:cNvSpPr>
+          <p:nvPr>
+            <p:ph type="sldImg"/>
+          </p:nvPr>
+        </p:nvSpPr>
+        <p:spPr/>
+      </p:sp>
+      <p:sp>
+        <p:nvSpPr>
+          <p:cNvPr id="3" name="Notes Placeholder 2"/>
+          <p:cNvSpPr>
+            <a:spLocks noGrp="1"/>
+          </p:cNvSpPr>
+          <p:nvPr>
+            <p:ph type="body" idx="1"/>
+          </p:nvPr>
+        </p:nvSpPr>
+        <p:spPr/>
+        <p:txBody>
+          <a:bodyPr/>
+          <a:lstStyle/>
+          <a:p>
+            <a:r>
+              <a:rPr lang="en-US" dirty="0"/>
+              <a:t>Somos cinco: Lucero en el planteamiento, Alexis en la generación y OpenSees, Nicolás en el módulo NSR-10, Jean Piere en datos, modelos E.030 y el bot, y Joseph en validación y coordinación. Agradecemos al profesor Thomas Rojas Vallejo por sus datos. Gracias.</a:t>
+            </a:r>
+            <a:endParaRPr lang="en-US" dirty="0"/>
+          </a:p>
+        </p:txBody>
+      </p:sp>
+      <p:sp>
+        <p:nvSpPr>
+          <p:cNvPr id="4" name="Slide Number Placeholder 3"/>
+          <p:cNvSpPr>
+            <a:spLocks noGrp="1"/>
+          </p:cNvSpPr>
+          <p:nvPr>
+            <p:ph type="sldNum" sz="quarter" idx="10"/>
+          </p:nvPr>
+        </p:nvSpPr>
+        <p:spPr/>
+        <p:txBody>
+          <a:bodyPr/>
+          <a:lstStyle/>
+          <a:p>
+            <a:fld id="{F7021451-1387-4CA6-816F-3879F97B5CBC}" type="slidenum">
+              <a:rPr lang="en-US"/>
+              <a:t>15</a:t>
             </a:fld>
             <a:endParaRPr lang="en-US"/>
           </a:p>
@@ -1451,7 +1541,7 @@
           <a:p>
             <a:r>
               <a:rPr lang="en-US" dirty="0"/>
-              <a:t>El problema: en el predimensionamiento cada alternativa obliga a repetir espectro, pesos, fuerzas, modelo y revisión de derivas. En nuestra base paramétrica de 130 modelos, un tercio supera el límite de deriva: es trabajo que se pudo descartar antes.</a:t>
+              <a:t>El problema: en el predimensionamiento cada alternativa obliga a repetir espectro, pesos, fuerzas, modelo y revisión de derivas. En nuestra base paramétrica de 1 500 edificios, el 45 % supera el límite de deriva: es trabajo que se pudo descartar antes.</a:t>
             </a:r>
             <a:endParaRPr lang="en-US" dirty="0"/>
           </a:p>
@@ -1539,7 +1629,7 @@
           <a:p>
             <a:r>
               <a:rPr lang="en-US" dirty="0"/>
-              <a:t>Nuestra pregunta es: ¿con qué precisión puede Random Forest estimar las derivas de edificios que no vio en el entrenamiento, y qué ventaja ofrece? Para responderla generamos familias paramétricas, automatizamos la verificación NSR-10 y evaluamos el modelo dejando plantas completas por fuera.</a:t>
+              <a:t>Nuestra pregunta es: ¿con qué precisión puede Random Forest estimar las derivas de edificios que no vio en el entrenamiento, y qué ventaja ofrece? Para responderla generamos familias paramétricas, automatizamos la verificación NSR-10 y evaluamos el modelo solo con edificios que no vio al entrenar.</a:t>
             </a:r>
             <a:endParaRPr lang="en-US" dirty="0"/>
           </a:p>
@@ -1715,7 +1805,7 @@
           <a:p>
             <a:r>
               <a:rPr lang="en-US" dirty="0"/>
-              <a:t>La arquitectura tiene dos rutas de evidencia que no se mezclan, porque las normas difieren: la ruta E.030 con 130 modelos paramétricos en OpenSees y la ruta NSR-10 con el módulo de verificación y los edificios del profesor Rojas Vallejo. Ambas alimentan el mismo método de Random Forest y la interfaz propuesta en Telegram.</a:t>
+              <a:t>La arquitectura tiene dos rutas de evidencia que no se mezclan, porque las normas difieren: la ruta E.030 con 1 500 edificios paramétricos en OpenSees y la ruta NSR-10 con el módulo de verificación y los edificios del profesor Rojas Vallejo. Ambas alimentan el mismo método de Random Forest y la interfaz propuesta en Telegram.</a:t>
             </a:r>
             <a:endParaRPr lang="en-US" dirty="0"/>
           </a:p>
@@ -2067,7 +2157,7 @@
           <a:p>
             <a:r>
               <a:rPr lang="en-US" dirty="0"/>
-              <a:t>Para la ruta NSR-10 armamos una base con 18 edificios que diseñó el profesor Rojas Vallejo con su algoritmo en OpenSees, más el caso del curso. El profesor nos advirtió que varios son teóricos y que las plantas que faltan fallaron en el dimensionamiento. Los usamos para entrenar y comparar, no como diseños.</a:t>
+              <a:t>Esta es la respuesta principal a la pregunta. En la ruta peruana generamos y analizamos 1 500 edificios en OpenSees. Entrenamos Random Forest con 1 200 y lo probamos una sola vez con 300 familias que nunca vio. Su error medio en la deriva fue de 0,04 puntos porcentuales, con R² de 0,99, y detectó 137 de los 146 edificios que exceden el límite. Los que se le escapan están justo en el límite, entre 0,70 y 0,76 %. Como comparación, Gradient Boosting mejora un poco: R² de 0,995 y 139 detectados. La diferencia entre algoritmos es pequeña; lo que manda son los datos y las variables físicas.</a:t>
             </a:r>
             <a:endParaRPr lang="en-US" dirty="0"/>
           </a:p>
@@ -3164,50 +3254,259 @@
                 <a:ea typeface="Cambria" pitchFamily="34" charset="-122"/>
                 <a:cs typeface="Cambria" pitchFamily="34" charset="-120"/>
               </a:rPr>
-              <a:t>Random Forest reduce 39 % el error de deriva</a:t>
+              <a:t>Base NSR-10: 18 edificios teóricos + 1 verificado</a:t>
             </a:r>
             <a:endParaRPr lang="en-US" sz="2800" dirty="0"/>
           </a:p>
         </p:txBody>
       </p:sp>
-      <p:graphicFrame>
-        <p:nvGraphicFramePr>
-          <p:cNvPr id="3" name="grafico_mae" descr=""/>
-          <p:cNvGraphicFramePr/>
-          <p:nvPr/>
-        </p:nvGraphicFramePr>
-        <p:xfrm>
-          <a:off x="457200" y="1097280"/>
-          <a:ext cx="5120640" cy="3474720"/>
-        </p:xfrm>
-        <a:graphic xmlns:a="http://schemas.openxmlformats.org/drawingml/2006/main">
-          <a:graphicData uri="http://schemas.openxmlformats.org/drawingml/2006/chart">
-            <c:chart xmlns:c="http://schemas.openxmlformats.org/drawingml/2006/chart" r:id="rId1"/>
-          </a:graphicData>
-        </a:graphic>
-      </p:graphicFrame>
-      <p:sp>
-        <p:nvSpPr>
-          <p:cNvPr id="4" name="stat"/>
+      <p:sp>
+        <p:nvSpPr>
+          <p:cNvPr id="3" name="Text 1"/>
+          <p:cNvSpPr txBox="1"/>
+          <p:nvPr/>
+        </p:nvSpPr>
+        <p:spPr>
+          <a:xfrm>
+            <a:off x="457200" y="1188720"/>
+            <a:ext cx="2560320" cy="777240"/>
+          </a:xfrm>
+          <a:prstGeom prst="rect">
+            <a:avLst/>
+          </a:prstGeom>
+          <a:noFill/>
+          <a:ln/>
+        </p:spPr>
+        <p:txBody>
+          <a:bodyPr wrap="square" lIns="0" tIns="0" rIns="0" bIns="0" rtlCol="0" anchor="t"/>
+          <a:lstStyle/>
+          <a:p>
+            <a:pPr indent="0" marL="0">
+              <a:buNone/>
+            </a:pPr>
+            <a:r>
+              <a:rPr lang="en-US" sz="4800" b="1" dirty="0">
+                <a:solidFill>
+                  <a:schemeClr val="accent1"/>
+                </a:solidFill>
+                <a:latin typeface="Cambria" pitchFamily="34" charset="0"/>
+                <a:ea typeface="Cambria" pitchFamily="34" charset="-122"/>
+                <a:cs typeface="Cambria" pitchFamily="34" charset="-120"/>
+              </a:rPr>
+              <a:t>18</a:t>
+            </a:r>
+            <a:endParaRPr lang="en-US" sz="4800" dirty="0"/>
+          </a:p>
+        </p:txBody>
+      </p:sp>
+      <p:sp>
+        <p:nvSpPr>
+          <p:cNvPr id="4" name="Text 2"/>
+          <p:cNvSpPr txBox="1"/>
+          <p:nvPr/>
+        </p:nvSpPr>
+        <p:spPr>
+          <a:xfrm>
+            <a:off x="457200" y="1965960"/>
+            <a:ext cx="2560320" cy="548640"/>
+          </a:xfrm>
+          <a:prstGeom prst="rect">
+            <a:avLst/>
+          </a:prstGeom>
+          <a:noFill/>
+          <a:ln/>
+        </p:spPr>
+        <p:txBody>
+          <a:bodyPr wrap="square" lIns="0" tIns="0" rIns="0" bIns="0" rtlCol="0" anchor="t"/>
+          <a:lstStyle/>
+          <a:p>
+            <a:pPr indent="0" marL="0">
+              <a:buNone/>
+            </a:pPr>
+            <a:r>
+              <a:rPr lang="en-US" sz="1400" dirty="0">
+                <a:solidFill>
+                  <a:schemeClr val="tx2"/>
+                </a:solidFill>
+              </a:rPr>
+              <a:t>edificios del Prof. T. F. Rojas Vallejo (OpenSees)</a:t>
+            </a:r>
+            <a:endParaRPr lang="en-US" sz="1400" dirty="0"/>
+          </a:p>
+        </p:txBody>
+      </p:sp>
+      <p:sp>
+        <p:nvSpPr>
+          <p:cNvPr id="5" name="Text 3"/>
+          <p:cNvSpPr txBox="1"/>
+          <p:nvPr/>
+        </p:nvSpPr>
+        <p:spPr>
+          <a:xfrm>
+            <a:off x="3291840" y="1188720"/>
+            <a:ext cx="2560320" cy="777240"/>
+          </a:xfrm>
+          <a:prstGeom prst="rect">
+            <a:avLst/>
+          </a:prstGeom>
+          <a:noFill/>
+          <a:ln/>
+        </p:spPr>
+        <p:txBody>
+          <a:bodyPr wrap="square" lIns="0" tIns="0" rIns="0" bIns="0" rtlCol="0" anchor="t"/>
+          <a:lstStyle/>
+          <a:p>
+            <a:pPr indent="0" marL="0">
+              <a:buNone/>
+            </a:pPr>
+            <a:r>
+              <a:rPr lang="en-US" sz="4800" b="1" dirty="0">
+                <a:solidFill>
+                  <a:schemeClr val="accent1"/>
+                </a:solidFill>
+                <a:latin typeface="Cambria" pitchFamily="34" charset="0"/>
+                <a:ea typeface="Cambria" pitchFamily="34" charset="-122"/>
+                <a:cs typeface="Cambria" pitchFamily="34" charset="-120"/>
+              </a:rPr>
+              <a:t>9</a:t>
+            </a:r>
+            <a:endParaRPr lang="en-US" sz="4800" dirty="0"/>
+          </a:p>
+        </p:txBody>
+      </p:sp>
+      <p:sp>
+        <p:nvSpPr>
+          <p:cNvPr id="6" name="Text 4"/>
+          <p:cNvSpPr txBox="1"/>
+          <p:nvPr/>
+        </p:nvSpPr>
+        <p:spPr>
+          <a:xfrm>
+            <a:off x="3291840" y="1965960"/>
+            <a:ext cx="2560320" cy="548640"/>
+          </a:xfrm>
+          <a:prstGeom prst="rect">
+            <a:avLst/>
+          </a:prstGeom>
+          <a:noFill/>
+          <a:ln/>
+        </p:spPr>
+        <p:txBody>
+          <a:bodyPr wrap="square" lIns="0" tIns="0" rIns="0" bIns="0" rtlCol="0" anchor="t"/>
+          <a:lstStyle/>
+          <a:p>
+            <a:pPr indent="0" marL="0">
+              <a:buNone/>
+            </a:pPr>
+            <a:r>
+              <a:rPr lang="en-US" sz="1400" dirty="0">
+                <a:solidFill>
+                  <a:schemeClr val="tx2"/>
+                </a:solidFill>
+              </a:rPr>
+              <a:t>plantas, 4 a 10 pisos, Bogotá, DES</a:t>
+            </a:r>
+            <a:endParaRPr lang="en-US" sz="1400" dirty="0"/>
+          </a:p>
+        </p:txBody>
+      </p:sp>
+      <p:sp>
+        <p:nvSpPr>
+          <p:cNvPr id="7" name="Text 5"/>
+          <p:cNvSpPr txBox="1"/>
+          <p:nvPr/>
+        </p:nvSpPr>
+        <p:spPr>
+          <a:xfrm>
+            <a:off x="6126480" y="1188720"/>
+            <a:ext cx="2560320" cy="777240"/>
+          </a:xfrm>
+          <a:prstGeom prst="rect">
+            <a:avLst/>
+          </a:prstGeom>
+          <a:noFill/>
+          <a:ln/>
+        </p:spPr>
+        <p:txBody>
+          <a:bodyPr wrap="square" lIns="0" tIns="0" rIns="0" bIns="0" rtlCol="0" anchor="t"/>
+          <a:lstStyle/>
+          <a:p>
+            <a:pPr indent="0" marL="0">
+              <a:buNone/>
+            </a:pPr>
+            <a:r>
+              <a:rPr lang="en-US" sz="4800" b="1" dirty="0">
+                <a:solidFill>
+                  <a:schemeClr val="accent1"/>
+                </a:solidFill>
+                <a:latin typeface="Cambria" pitchFamily="34" charset="0"/>
+                <a:ea typeface="Cambria" pitchFamily="34" charset="-122"/>
+                <a:cs typeface="Cambria" pitchFamily="34" charset="-120"/>
+              </a:rPr>
+              <a:t>1</a:t>
+            </a:r>
+            <a:endParaRPr lang="en-US" sz="4800" dirty="0"/>
+          </a:p>
+        </p:txBody>
+      </p:sp>
+      <p:sp>
+        <p:nvSpPr>
+          <p:cNvPr id="8" name="Text 6"/>
+          <p:cNvSpPr txBox="1"/>
+          <p:nvPr/>
+        </p:nvSpPr>
+        <p:spPr>
+          <a:xfrm>
+            <a:off x="6126480" y="1965960"/>
+            <a:ext cx="2560320" cy="548640"/>
+          </a:xfrm>
+          <a:prstGeom prst="rect">
+            <a:avLst/>
+          </a:prstGeom>
+          <a:noFill/>
+          <a:ln/>
+        </p:spPr>
+        <p:txBody>
+          <a:bodyPr wrap="square" lIns="0" tIns="0" rIns="0" bIns="0" rtlCol="0" anchor="t"/>
+          <a:lstStyle/>
+          <a:p>
+            <a:pPr indent="0" marL="0">
+              <a:buNone/>
+            </a:pPr>
+            <a:r>
+              <a:rPr lang="en-US" sz="1400" dirty="0">
+                <a:solidFill>
+                  <a:schemeClr val="tx2"/>
+                </a:solidFill>
+              </a:rPr>
+              <a:t>caso del curso verificado con SAP2000</a:t>
+            </a:r>
+            <a:endParaRPr lang="en-US" sz="1400" dirty="0"/>
+          </a:p>
+        </p:txBody>
+      </p:sp>
+      <p:sp>
+        <p:nvSpPr>
+          <p:cNvPr id="9" name="nota_profesor"/>
           <p:cNvSpPr/>
           <p:nvPr/>
         </p:nvSpPr>
         <p:spPr>
           <a:xfrm>
-            <a:off x="5852160" y="1188720"/>
-            <a:ext cx="2834640" cy="1463040"/>
+            <a:off x="457200" y="2788920"/>
+            <a:ext cx="8229600" cy="1691640"/>
           </a:xfrm>
           <a:prstGeom prst="roundRect">
             <a:avLst>
-              <a:gd name="adj" fmla="val 5000"/>
+              <a:gd name="adj" fmla="val 4324"/>
             </a:avLst>
           </a:prstGeom>
           <a:solidFill>
-            <a:schemeClr val="bg2"/>
+            <a:srgbClr val="EDF0F3"/>
           </a:solidFill>
           <a:ln w="12700">
             <a:solidFill>
-              <a:schemeClr val="bg2"/>
+              <a:srgbClr val="EDF0F3"/>
             </a:solidFill>
             <a:prstDash val="solid"/>
           </a:ln>
@@ -3215,116 +3514,63 @@
       </p:sp>
       <p:sp>
         <p:nvSpPr>
-          <p:cNvPr id="5" name="Text 2"/>
-          <p:cNvSpPr txBox="1"/>
-          <p:nvPr/>
-        </p:nvSpPr>
-        <p:spPr>
-          <a:xfrm>
-            <a:off x="6035040" y="1280160"/>
-            <a:ext cx="2560320" cy="731520"/>
-          </a:xfrm>
-          <a:prstGeom prst="rect">
-            <a:avLst/>
-          </a:prstGeom>
-          <a:noFill/>
-          <a:ln/>
-        </p:spPr>
-        <p:txBody>
-          <a:bodyPr wrap="square" lIns="0" tIns="0" rIns="0" bIns="0" rtlCol="0" anchor="t"/>
-          <a:lstStyle/>
-          <a:p>
-            <a:pPr indent="0" marL="0">
-              <a:buNone/>
-            </a:pPr>
-            <a:r>
-              <a:rPr lang="en-US" sz="4000" b="1" dirty="0">
-                <a:solidFill>
-                  <a:schemeClr val="accent1"/>
-                </a:solidFill>
-                <a:latin typeface="Cambria" pitchFamily="34" charset="0"/>
-                <a:ea typeface="Cambria" pitchFamily="34" charset="-122"/>
-                <a:cs typeface="Cambria" pitchFamily="34" charset="-120"/>
-              </a:rPr>
-              <a:t>−39 %</a:t>
-            </a:r>
-            <a:endParaRPr lang="en-US" sz="4000" dirty="0"/>
-          </a:p>
-        </p:txBody>
-      </p:sp>
-      <p:sp>
-        <p:nvSpPr>
-          <p:cNvPr id="6" name="Text 3"/>
-          <p:cNvSpPr txBox="1"/>
-          <p:nvPr/>
-        </p:nvSpPr>
-        <p:spPr>
-          <a:xfrm>
-            <a:off x="6035040" y="2011680"/>
-            <a:ext cx="2560320" cy="548640"/>
-          </a:xfrm>
-          <a:prstGeom prst="rect">
-            <a:avLst/>
-          </a:prstGeom>
-          <a:noFill/>
-          <a:ln/>
-        </p:spPr>
-        <p:txBody>
-          <a:bodyPr wrap="square" lIns="0" tIns="0" rIns="0" bIns="0" rtlCol="0" anchor="t"/>
-          <a:lstStyle/>
-          <a:p>
-            <a:pPr indent="0" marL="0">
-              <a:buNone/>
-            </a:pPr>
-            <a:r>
-              <a:rPr lang="en-US" sz="1300" dirty="0">
-                <a:solidFill>
-                  <a:schemeClr val="tx2"/>
-                </a:solidFill>
-              </a:rPr>
-              <a:t>error de deriva frente a predecir la media</a:t>
-            </a:r>
-            <a:endParaRPr lang="en-US" sz="1300" dirty="0"/>
-          </a:p>
-        </p:txBody>
-      </p:sp>
-      <p:sp>
-        <p:nvSpPr>
-          <p:cNvPr id="7" name="stat"/>
+          <p:cNvPr id="10" name="badge"/>
           <p:cNvSpPr/>
           <p:nvPr/>
         </p:nvSpPr>
         <p:spPr>
           <a:xfrm>
-            <a:off x="5852160" y="2926080"/>
-            <a:ext cx="2834640" cy="1463040"/>
-          </a:xfrm>
-          <a:prstGeom prst="roundRect">
-            <a:avLst>
-              <a:gd name="adj" fmla="val 5000"/>
-            </a:avLst>
+            <a:off x="685800" y="3017520"/>
+            <a:ext cx="502920" cy="502920"/>
+          </a:xfrm>
+          <a:prstGeom prst="ellipse">
+            <a:avLst/>
           </a:prstGeom>
           <a:solidFill>
-            <a:schemeClr val="bg2"/>
+            <a:schemeClr val="accent5"/>
           </a:solidFill>
           <a:ln w="12700">
             <a:solidFill>
-              <a:schemeClr val="bg2"/>
+              <a:schemeClr val="accent5"/>
             </a:solidFill>
             <a:prstDash val="solid"/>
           </a:ln>
         </p:spPr>
       </p:sp>
-      <p:sp>
-        <p:nvSpPr>
-          <p:cNvPr id="8" name="Text 5"/>
+      <p:pic>
+        <p:nvPicPr>
+          <p:cNvPr id="11" name="icono" descr="preencoded.png">    </p:cNvPr>
+          <p:cNvPicPr>
+            <a:picLocks noChangeAspect="1"/>
+          </p:cNvPicPr>
+          <p:nvPr/>
+        </p:nvPicPr>
+        <p:blipFill>
+          <a:blip r:embed="rId1"/>
+          <a:stretch>
+            <a:fillRect/>
+          </a:stretch>
+        </p:blipFill>
+        <p:spPr>
+          <a:xfrm>
+            <a:off x="796442" y="3128162"/>
+            <a:ext cx="281635" cy="281635"/>
+          </a:xfrm>
+          <a:prstGeom prst="rect">
+            <a:avLst/>
+          </a:prstGeom>
+        </p:spPr>
+      </p:pic>
+      <p:sp>
+        <p:nvSpPr>
+          <p:cNvPr id="12" name="Text 9"/>
           <p:cNvSpPr txBox="1"/>
           <p:nvPr/>
         </p:nvSpPr>
         <p:spPr>
           <a:xfrm>
-            <a:off x="6035040" y="3017520"/>
-            <a:ext cx="2560320" cy="731520"/>
+            <a:off x="1371600" y="3017520"/>
+            <a:ext cx="7132320" cy="320040"/>
           </a:xfrm>
           <a:prstGeom prst="rect">
             <a:avLst/>
@@ -3340,30 +3586,27 @@
               <a:buNone/>
             </a:pPr>
             <a:r>
-              <a:rPr lang="en-US" sz="4000" b="1" dirty="0">
-                <a:solidFill>
-                  <a:schemeClr val="accent1"/>
-                </a:solidFill>
-                <a:latin typeface="Cambria" pitchFamily="34" charset="0"/>
-                <a:ea typeface="Cambria" pitchFamily="34" charset="-122"/>
-                <a:cs typeface="Cambria" pitchFamily="34" charset="-120"/>
-              </a:rPr>
-              <a:t>32 ms</a:t>
-            </a:r>
-            <a:endParaRPr lang="en-US" sz="4000" dirty="0"/>
-          </a:p>
-        </p:txBody>
-      </p:sp>
-      <p:sp>
-        <p:nvSpPr>
-          <p:cNvPr id="9" name="Text 6"/>
+              <a:rPr lang="en-US" sz="1500" b="1" dirty="0">
+                <a:solidFill>
+                  <a:schemeClr val="tx1"/>
+                </a:solidFill>
+              </a:rPr>
+              <a:t>Nota del profesor</a:t>
+            </a:r>
+            <a:endParaRPr lang="en-US" sz="1500" dirty="0"/>
+          </a:p>
+        </p:txBody>
+      </p:sp>
+      <p:sp>
+        <p:nvSpPr>
+          <p:cNvPr id="13" name="Text 10"/>
           <p:cNvSpPr txBox="1"/>
           <p:nvPr/>
         </p:nvSpPr>
         <p:spPr>
           <a:xfrm>
-            <a:off x="6035040" y="3749040"/>
-            <a:ext cx="2560320" cy="548640"/>
+            <a:off x="1371600" y="3383280"/>
+            <a:ext cx="7132320" cy="1005840"/>
           </a:xfrm>
           <a:prstGeom prst="rect">
             <a:avLst/>
@@ -3384,45 +3627,9 @@
                   <a:schemeClr val="tx2"/>
                 </a:solidFill>
               </a:rPr>
-              <a:t>por predicción; entrenar toma 0,4 s</a:t>
+              <a:t>Varios resultados son teóricos: algunas plantas y luces no se resolverían con pórticos resistentes a momento en la práctica. Las plantas ausentes fallaron en el dimensionamiento del algoritmo de OpenSees. Por eso estos datos sirven para entrenar y comparar, no como diseños.</a:t>
             </a:r>
             <a:endParaRPr lang="en-US" sz="1300" dirty="0"/>
-          </a:p>
-        </p:txBody>
-      </p:sp>
-      <p:sp>
-        <p:nvSpPr>
-          <p:cNvPr id="10" name="Text 7"/>
-          <p:cNvSpPr txBox="1"/>
-          <p:nvPr/>
-        </p:nvSpPr>
-        <p:spPr>
-          <a:xfrm>
-            <a:off x="457200" y="4526280"/>
-            <a:ext cx="5120640" cy="228600"/>
-          </a:xfrm>
-          <a:prstGeom prst="rect">
-            <a:avLst/>
-          </a:prstGeom>
-          <a:noFill/>
-          <a:ln/>
-        </p:spPr>
-        <p:txBody>
-          <a:bodyPr wrap="square" lIns="0" tIns="0" rIns="0" bIns="0" rtlCol="0" anchor="t"/>
-          <a:lstStyle/>
-          <a:p>
-            <a:pPr indent="0" marL="0">
-              <a:buNone/>
-            </a:pPr>
-            <a:r>
-              <a:rPr lang="en-US" sz="1000" i="1" dirty="0">
-                <a:solidFill>
-                  <a:schemeClr val="accent2"/>
-                </a:solidFill>
-              </a:rPr>
-              <a:t>Validación dejando una planta completa fuera (9 pliegues).</a:t>
-            </a:r>
-            <a:endParaRPr lang="en-US" sz="1000" dirty="0"/>
           </a:p>
         </p:txBody>
       </p:sp>
@@ -3531,70 +3738,54 @@
                 <a:ea typeface="Cambria" pitchFamily="34" charset="-122"/>
                 <a:cs typeface="Cambria" pitchFamily="34" charset="-120"/>
               </a:rPr>
-              <a:t>Útil para priorizar, aún no para certificar</a:t>
+              <a:t>NSR-10: con 18 edificios, −39 % de error de deriva</a:t>
             </a:r>
             <a:endParaRPr lang="en-US" sz="2800" dirty="0"/>
           </a:p>
         </p:txBody>
       </p:sp>
-      <p:pic>
-        <p:nvPicPr>
-          <p:cNvPr id="3" name="calc_pred" descr="figuras/fig_calculado_vs_predicho.png">    </p:cNvPr>
-          <p:cNvPicPr>
-            <a:picLocks noChangeAspect="1"/>
-          </p:cNvPicPr>
-          <p:nvPr/>
-        </p:nvPicPr>
-        <p:blipFill>
-          <a:blip r:embed="rId1"/>
-          <a:srcRect l="0" r="0" t="0" b="0"/>
-          <a:stretch/>
-        </p:blipFill>
-        <p:spPr>
-          <a:xfrm>
-            <a:off x="457200" y="1097280"/>
-            <a:ext cx="5120640" cy="2743200"/>
-          </a:xfrm>
-          <a:prstGeom prst="rect">
-            <a:avLst/>
-          </a:prstGeom>
-        </p:spPr>
-      </p:pic>
-      <p:sp>
-        <p:nvSpPr>
-          <p:cNvPr id="4" name="Text 1"/>
-          <p:cNvSpPr txBox="1"/>
-          <p:nvPr/>
-        </p:nvSpPr>
-        <p:spPr>
-          <a:xfrm>
-            <a:off x="457200" y="3931920"/>
-            <a:ext cx="5120640" cy="457200"/>
-          </a:xfrm>
-          <a:prstGeom prst="rect">
-            <a:avLst/>
-          </a:prstGeom>
-          <a:noFill/>
-          <a:ln/>
-        </p:spPr>
-        <p:txBody>
-          <a:bodyPr wrap="square" lIns="0" tIns="0" rIns="0" bIns="0" rtlCol="0" anchor="t"/>
-          <a:lstStyle/>
-          <a:p>
-            <a:pPr indent="0" marL="0">
-              <a:buNone/>
-            </a:pPr>
-            <a:r>
-              <a:rPr lang="en-US" sz="1100" i="1" dirty="0">
-                <a:solidFill>
-                  <a:schemeClr val="tx2"/>
-                </a:solidFill>
-              </a:rPr>
-              <a:t>Deriva calculada (OpenSees, profesor) frente a predicha por Random Forest en plantas no vistas.</a:t>
-            </a:r>
-            <a:endParaRPr lang="en-US" sz="1100" dirty="0"/>
-          </a:p>
-        </p:txBody>
+      <p:graphicFrame>
+        <p:nvGraphicFramePr>
+          <p:cNvPr id="3" name="grafico_mae" descr=""/>
+          <p:cNvGraphicFramePr/>
+          <p:nvPr/>
+        </p:nvGraphicFramePr>
+        <p:xfrm>
+          <a:off x="457200" y="1097280"/>
+          <a:ext cx="5120640" cy="3474720"/>
+        </p:xfrm>
+        <a:graphic xmlns:a="http://schemas.openxmlformats.org/drawingml/2006/main">
+          <a:graphicData uri="http://schemas.openxmlformats.org/drawingml/2006/chart">
+            <c:chart xmlns:c="http://schemas.openxmlformats.org/drawingml/2006/chart" r:id="rId1"/>
+          </a:graphicData>
+        </a:graphic>
+      </p:graphicFrame>
+      <p:sp>
+        <p:nvSpPr>
+          <p:cNvPr id="4" name="stat"/>
+          <p:cNvSpPr/>
+          <p:nvPr/>
+        </p:nvSpPr>
+        <p:spPr>
+          <a:xfrm>
+            <a:off x="5852160" y="1188720"/>
+            <a:ext cx="2834640" cy="1463040"/>
+          </a:xfrm>
+          <a:prstGeom prst="roundRect">
+            <a:avLst>
+              <a:gd name="adj" fmla="val 5000"/>
+            </a:avLst>
+          </a:prstGeom>
+          <a:solidFill>
+            <a:schemeClr val="bg2"/>
+          </a:solidFill>
+          <a:ln w="12700">
+            <a:solidFill>
+              <a:schemeClr val="bg2"/>
+            </a:solidFill>
+            <a:prstDash val="solid"/>
+          </a:ln>
+        </p:spPr>
       </p:sp>
       <p:sp>
         <p:nvSpPr>
@@ -3604,8 +3795,8 @@
         </p:nvSpPr>
         <p:spPr>
           <a:xfrm>
-            <a:off x="5852160" y="1188720"/>
-            <a:ext cx="2834640" cy="777240"/>
+            <a:off x="6035040" y="1280160"/>
+            <a:ext cx="2560320" cy="731520"/>
           </a:xfrm>
           <a:prstGeom prst="rect">
             <a:avLst/>
@@ -3621,7 +3812,7 @@
               <a:buNone/>
             </a:pPr>
             <a:r>
-              <a:rPr lang="en-US" sz="4800" b="1" dirty="0">
+              <a:rPr lang="en-US" sz="4000" b="1" dirty="0">
                 <a:solidFill>
                   <a:schemeClr val="accent1"/>
                 </a:solidFill>
@@ -3629,9 +3820,9 @@
                 <a:ea typeface="Cambria" pitchFamily="34" charset="-122"/>
                 <a:cs typeface="Cambria" pitchFamily="34" charset="-120"/>
               </a:rPr>
-              <a:t>3 de 7</a:t>
-            </a:r>
-            <a:endParaRPr lang="en-US" sz="4800" dirty="0"/>
+              <a:t>−39 %</a:t>
+            </a:r>
+            <a:endParaRPr lang="en-US" sz="4000" dirty="0"/>
           </a:p>
         </p:txBody>
       </p:sp>
@@ -3643,8 +3834,8 @@
         </p:nvSpPr>
         <p:spPr>
           <a:xfrm>
-            <a:off x="5852160" y="1965960"/>
-            <a:ext cx="2834640" cy="548640"/>
+            <a:off x="6035040" y="2011680"/>
+            <a:ext cx="2560320" cy="548640"/>
           </a:xfrm>
           <a:prstGeom prst="rect">
             <a:avLst/>
@@ -3660,27 +3851,54 @@
               <a:buNone/>
             </a:pPr>
             <a:r>
-              <a:rPr lang="en-US" sz="1400" dirty="0">
+              <a:rPr lang="en-US" sz="1300" dirty="0">
                 <a:solidFill>
                   <a:schemeClr val="tx2"/>
                 </a:solidFill>
               </a:rPr>
-              <a:t>edificios con deriva ≥ 0,90 % detectados por el modelo</a:t>
-            </a:r>
-            <a:endParaRPr lang="en-US" sz="1400" dirty="0"/>
-          </a:p>
-        </p:txBody>
-      </p:sp>
-      <p:sp>
-        <p:nvSpPr>
-          <p:cNvPr id="7" name="Text 4"/>
+              <a:t>error de deriva frente a predecir la media</a:t>
+            </a:r>
+            <a:endParaRPr lang="en-US" sz="1300" dirty="0"/>
+          </a:p>
+        </p:txBody>
+      </p:sp>
+      <p:sp>
+        <p:nvSpPr>
+          <p:cNvPr id="7" name="stat"/>
+          <p:cNvSpPr/>
+          <p:nvPr/>
+        </p:nvSpPr>
+        <p:spPr>
+          <a:xfrm>
+            <a:off x="5852160" y="2926080"/>
+            <a:ext cx="2834640" cy="1463040"/>
+          </a:xfrm>
+          <a:prstGeom prst="roundRect">
+            <a:avLst>
+              <a:gd name="adj" fmla="val 5000"/>
+            </a:avLst>
+          </a:prstGeom>
+          <a:solidFill>
+            <a:schemeClr val="bg2"/>
+          </a:solidFill>
+          <a:ln w="12700">
+            <a:solidFill>
+              <a:schemeClr val="bg2"/>
+            </a:solidFill>
+            <a:prstDash val="solid"/>
+          </a:ln>
+        </p:spPr>
+      </p:sp>
+      <p:sp>
+        <p:nvSpPr>
+          <p:cNvPr id="8" name="Text 5"/>
           <p:cNvSpPr txBox="1"/>
           <p:nvPr/>
         </p:nvSpPr>
         <p:spPr>
           <a:xfrm>
-            <a:off x="5852160" y="2697480"/>
-            <a:ext cx="2834640" cy="777240"/>
+            <a:off x="6035040" y="3017520"/>
+            <a:ext cx="2560320" cy="731520"/>
           </a:xfrm>
           <a:prstGeom prst="rect">
             <a:avLst/>
@@ -3696,30 +3914,30 @@
               <a:buNone/>
             </a:pPr>
             <a:r>
-              <a:rPr lang="en-US" sz="4800" b="1" dirty="0">
-                <a:solidFill>
-                  <a:schemeClr val="accent3"/>
+              <a:rPr lang="en-US" sz="4000" b="1" dirty="0">
+                <a:solidFill>
+                  <a:schemeClr val="accent1"/>
                 </a:solidFill>
                 <a:latin typeface="Cambria" pitchFamily="34" charset="0"/>
                 <a:ea typeface="Cambria" pitchFamily="34" charset="-122"/>
                 <a:cs typeface="Cambria" pitchFamily="34" charset="-120"/>
               </a:rPr>
-              <a:t>0</a:t>
-            </a:r>
-            <a:endParaRPr lang="en-US" sz="4800" dirty="0"/>
-          </a:p>
-        </p:txBody>
-      </p:sp>
-      <p:sp>
-        <p:nvSpPr>
-          <p:cNvPr id="8" name="Text 5"/>
+              <a:t>32 ms</a:t>
+            </a:r>
+            <a:endParaRPr lang="en-US" sz="4000" dirty="0"/>
+          </a:p>
+        </p:txBody>
+      </p:sp>
+      <p:sp>
+        <p:nvSpPr>
+          <p:cNvPr id="9" name="Text 6"/>
           <p:cNvSpPr txBox="1"/>
           <p:nvPr/>
         </p:nvSpPr>
         <p:spPr>
           <a:xfrm>
-            <a:off x="5852160" y="3474720"/>
-            <a:ext cx="2834640" cy="731520"/>
+            <a:off x="6035040" y="3749040"/>
+            <a:ext cx="2560320" cy="548640"/>
           </a:xfrm>
           <a:prstGeom prst="rect">
             <a:avLst/>
@@ -3735,14 +3953,50 @@
               <a:buNone/>
             </a:pPr>
             <a:r>
-              <a:rPr lang="en-US" sz="1400" dirty="0">
+              <a:rPr lang="en-US" sz="1300" dirty="0">
                 <a:solidFill>
                   <a:schemeClr val="tx2"/>
                 </a:solidFill>
               </a:rPr>
-              <a:t>falsas alarmas; el modelo subestima los casos más cercanos al límite</a:t>
-            </a:r>
-            <a:endParaRPr lang="en-US" sz="1400" dirty="0"/>
+              <a:t>por predicción; entrenar toma 0,4 s</a:t>
+            </a:r>
+            <a:endParaRPr lang="en-US" sz="1300" dirty="0"/>
+          </a:p>
+        </p:txBody>
+      </p:sp>
+      <p:sp>
+        <p:nvSpPr>
+          <p:cNvPr id="10" name="Text 7"/>
+          <p:cNvSpPr txBox="1"/>
+          <p:nvPr/>
+        </p:nvSpPr>
+        <p:spPr>
+          <a:xfrm>
+            <a:off x="457200" y="4526280"/>
+            <a:ext cx="5120640" cy="228600"/>
+          </a:xfrm>
+          <a:prstGeom prst="rect">
+            <a:avLst/>
+          </a:prstGeom>
+          <a:noFill/>
+          <a:ln/>
+        </p:spPr>
+        <p:txBody>
+          <a:bodyPr wrap="square" lIns="0" tIns="0" rIns="0" bIns="0" rtlCol="0" anchor="t"/>
+          <a:lstStyle/>
+          <a:p>
+            <a:pPr indent="0" marL="0">
+              <a:buNone/>
+            </a:pPr>
+            <a:r>
+              <a:rPr lang="en-US" sz="1000" i="1" dirty="0">
+                <a:solidFill>
+                  <a:schemeClr val="accent2"/>
+                </a:solidFill>
+              </a:rPr>
+              <a:t>Validación dejando una planta completa fuera (9 pliegues).</a:t>
+            </a:r>
+            <a:endParaRPr lang="en-US" sz="1000" dirty="0"/>
           </a:p>
         </p:txBody>
       </p:sp>
@@ -3851,40 +4105,15 @@
                 <a:ea typeface="Cambria" pitchFamily="34" charset="-122"/>
                 <a:cs typeface="Cambria" pitchFamily="34" charset="-120"/>
               </a:rPr>
-              <a:t>Limitaciones que condicionan los resultados</a:t>
+              <a:t>NSR-10: con pocos datos, útil solo para priorizar</a:t>
             </a:r>
             <a:endParaRPr lang="en-US" sz="2800" dirty="0"/>
           </a:p>
         </p:txBody>
-      </p:sp>
-      <p:sp>
-        <p:nvSpPr>
-          <p:cNvPr id="3" name="badge"/>
-          <p:cNvSpPr/>
-          <p:nvPr/>
-        </p:nvSpPr>
-        <p:spPr>
-          <a:xfrm>
-            <a:off x="457200" y="1280160"/>
-            <a:ext cx="548640" cy="548640"/>
-          </a:xfrm>
-          <a:prstGeom prst="ellipse">
-            <a:avLst/>
-          </a:prstGeom>
-          <a:solidFill>
-            <a:schemeClr val="accent2"/>
-          </a:solidFill>
-          <a:ln w="12700">
-            <a:solidFill>
-              <a:schemeClr val="accent2"/>
-            </a:solidFill>
-            <a:prstDash val="solid"/>
-          </a:ln>
-        </p:spPr>
       </p:sp>
       <p:pic>
         <p:nvPicPr>
-          <p:cNvPr id="4" name="icono" descr="preencoded.png">    </p:cNvPr>
+          <p:cNvPr id="3" name="calc_pred" descr="C:\Users\nicoi\Documents\AECODE Nexo Sismico\07 Outputs\Prototipo NSR-10\figuras\fig_calculado_vs_predicho.png">    </p:cNvPr>
           <p:cNvPicPr>
             <a:picLocks noChangeAspect="1"/>
           </p:cNvPicPr>
@@ -3892,20 +4121,55 @@
         </p:nvPicPr>
         <p:blipFill>
           <a:blip r:embed="rId1"/>
-          <a:stretch>
-            <a:fillRect/>
-          </a:stretch>
+          <a:srcRect l="0" r="0" t="0" b="0"/>
+          <a:stretch/>
         </p:blipFill>
         <p:spPr>
           <a:xfrm>
-            <a:off x="577901" y="1400861"/>
-            <a:ext cx="307238" cy="307238"/>
+            <a:off x="457200" y="1097280"/>
+            <a:ext cx="5120640" cy="2743200"/>
           </a:xfrm>
           <a:prstGeom prst="rect">
             <a:avLst/>
           </a:prstGeom>
         </p:spPr>
       </p:pic>
+      <p:sp>
+        <p:nvSpPr>
+          <p:cNvPr id="4" name="Text 1"/>
+          <p:cNvSpPr txBox="1"/>
+          <p:nvPr/>
+        </p:nvSpPr>
+        <p:spPr>
+          <a:xfrm>
+            <a:off x="457200" y="3931920"/>
+            <a:ext cx="5120640" cy="457200"/>
+          </a:xfrm>
+          <a:prstGeom prst="rect">
+            <a:avLst/>
+          </a:prstGeom>
+          <a:noFill/>
+          <a:ln/>
+        </p:spPr>
+        <p:txBody>
+          <a:bodyPr wrap="square" lIns="0" tIns="0" rIns="0" bIns="0" rtlCol="0" anchor="t"/>
+          <a:lstStyle/>
+          <a:p>
+            <a:pPr indent="0" marL="0">
+              <a:buNone/>
+            </a:pPr>
+            <a:r>
+              <a:rPr lang="en-US" sz="1100" i="1" dirty="0">
+                <a:solidFill>
+                  <a:schemeClr val="tx2"/>
+                </a:solidFill>
+              </a:rPr>
+              <a:t>Deriva calculada (OpenSees, profesor) frente a predicha por Random Forest en plantas no vistas.</a:t>
+            </a:r>
+            <a:endParaRPr lang="en-US" sz="1100" dirty="0"/>
+          </a:p>
+        </p:txBody>
+      </p:sp>
       <p:sp>
         <p:nvSpPr>
           <p:cNvPr id="5" name="Text 2"/>
@@ -3914,8 +4178,8 @@
         </p:nvSpPr>
         <p:spPr>
           <a:xfrm>
-            <a:off x="1188720" y="1234440"/>
-            <a:ext cx="3200400" cy="365760"/>
+            <a:off x="5852160" y="1188720"/>
+            <a:ext cx="2834640" cy="777240"/>
           </a:xfrm>
           <a:prstGeom prst="rect">
             <a:avLst/>
@@ -3931,14 +4195,17 @@
               <a:buNone/>
             </a:pPr>
             <a:r>
-              <a:rPr lang="en-US" sz="1600" b="1" dirty="0">
-                <a:solidFill>
-                  <a:schemeClr val="tx1"/>
-                </a:solidFill>
-              </a:rPr>
-              <a:t>Base NSR-10 pequeña y teórica</a:t>
-            </a:r>
-            <a:endParaRPr lang="en-US" sz="1600" dirty="0"/>
+              <a:rPr lang="en-US" sz="4800" b="1" dirty="0">
+                <a:solidFill>
+                  <a:schemeClr val="accent1"/>
+                </a:solidFill>
+                <a:latin typeface="Cambria" pitchFamily="34" charset="0"/>
+                <a:ea typeface="Cambria" pitchFamily="34" charset="-122"/>
+                <a:cs typeface="Cambria" pitchFamily="34" charset="-120"/>
+              </a:rPr>
+              <a:t>3 de 7</a:t>
+            </a:r>
+            <a:endParaRPr lang="en-US" sz="4800" dirty="0"/>
           </a:p>
         </p:txBody>
       </p:sp>
@@ -3950,8 +4217,8 @@
         </p:nvSpPr>
         <p:spPr>
           <a:xfrm>
-            <a:off x="1188720" y="1645920"/>
-            <a:ext cx="3200400" cy="822960"/>
+            <a:off x="5852160" y="1965960"/>
+            <a:ext cx="2834640" cy="548640"/>
           </a:xfrm>
           <a:prstGeom prst="rect">
             <a:avLst/>
@@ -3972,7 +4239,7 @@
                   <a:schemeClr val="tx2"/>
                 </a:solidFill>
               </a:rPr>
-              <a:t>18 edificios; varias configuraciones no serían viables en pórticos reales</a:t>
+              <a:t>edificios con deriva ≥ 0,90 % detectados por el modelo</a:t>
             </a:r>
             <a:endParaRPr lang="en-US" sz="1400" dirty="0"/>
           </a:p>
@@ -3980,63 +4247,14 @@
       </p:sp>
       <p:sp>
         <p:nvSpPr>
-          <p:cNvPr id="7" name="badge"/>
-          <p:cNvSpPr/>
-          <p:nvPr/>
-        </p:nvSpPr>
-        <p:spPr>
-          <a:xfrm>
-            <a:off x="4663440" y="1280160"/>
-            <a:ext cx="548640" cy="548640"/>
-          </a:xfrm>
-          <a:prstGeom prst="ellipse">
-            <a:avLst/>
-          </a:prstGeom>
-          <a:solidFill>
-            <a:schemeClr val="accent2"/>
-          </a:solidFill>
-          <a:ln w="12700">
-            <a:solidFill>
-              <a:schemeClr val="accent2"/>
-            </a:solidFill>
-            <a:prstDash val="solid"/>
-          </a:ln>
-        </p:spPr>
-      </p:sp>
-      <p:pic>
-        <p:nvPicPr>
-          <p:cNvPr id="8" name="icono" descr="preencoded.png">    </p:cNvPr>
-          <p:cNvPicPr>
-            <a:picLocks noChangeAspect="1"/>
-          </p:cNvPicPr>
-          <p:nvPr/>
-        </p:nvPicPr>
-        <p:blipFill>
-          <a:blip r:embed="rId2"/>
-          <a:stretch>
-            <a:fillRect/>
-          </a:stretch>
-        </p:blipFill>
-        <p:spPr>
-          <a:xfrm>
-            <a:off x="4784141" y="1400861"/>
-            <a:ext cx="307238" cy="307238"/>
-          </a:xfrm>
-          <a:prstGeom prst="rect">
-            <a:avLst/>
-          </a:prstGeom>
-        </p:spPr>
-      </p:pic>
-      <p:sp>
-        <p:nvSpPr>
-          <p:cNvPr id="9" name="Text 5"/>
+          <p:cNvPr id="7" name="Text 4"/>
           <p:cNvSpPr txBox="1"/>
           <p:nvPr/>
         </p:nvSpPr>
         <p:spPr>
           <a:xfrm>
-            <a:off x="5394960" y="1234440"/>
-            <a:ext cx="3200400" cy="365760"/>
+            <a:off x="5852160" y="2697480"/>
+            <a:ext cx="2834640" cy="777240"/>
           </a:xfrm>
           <a:prstGeom prst="rect">
             <a:avLst/>
@@ -4052,27 +4270,30 @@
               <a:buNone/>
             </a:pPr>
             <a:r>
-              <a:rPr lang="en-US" sz="1600" b="1" dirty="0">
-                <a:solidFill>
-                  <a:schemeClr val="tx1"/>
-                </a:solidFill>
-              </a:rPr>
-              <a:t>Ruta E.030 sin evaluar todavía</a:t>
-            </a:r>
-            <a:endParaRPr lang="en-US" sz="1600" dirty="0"/>
-          </a:p>
-        </p:txBody>
-      </p:sp>
-      <p:sp>
-        <p:nvSpPr>
-          <p:cNvPr id="10" name="Text 6"/>
+              <a:rPr lang="en-US" sz="4800" b="1" dirty="0">
+                <a:solidFill>
+                  <a:schemeClr val="accent3"/>
+                </a:solidFill>
+                <a:latin typeface="Cambria" pitchFamily="34" charset="0"/>
+                <a:ea typeface="Cambria" pitchFamily="34" charset="-122"/>
+                <a:cs typeface="Cambria" pitchFamily="34" charset="-120"/>
+              </a:rPr>
+              <a:t>0</a:t>
+            </a:r>
+            <a:endParaRPr lang="en-US" sz="4800" dirty="0"/>
+          </a:p>
+        </p:txBody>
+      </p:sp>
+      <p:sp>
+        <p:nvSpPr>
+          <p:cNvPr id="8" name="Text 5"/>
           <p:cNvSpPr txBox="1"/>
           <p:nvPr/>
         </p:nvSpPr>
         <p:spPr>
           <a:xfrm>
-            <a:off x="5394960" y="1645920"/>
-            <a:ext cx="3200400" cy="822960"/>
+            <a:off x="5852160" y="3474720"/>
+            <a:ext cx="2834640" cy="731520"/>
           </a:xfrm>
           <a:prstGeom prst="rect">
             <a:avLst/>
@@ -4093,249 +4314,7 @@
                   <a:schemeClr val="tx2"/>
                 </a:solidFill>
               </a:rPr>
-              <a:t>Faltan las métricas del Random Forest en las familias reservadas</a:t>
-            </a:r>
-            <a:endParaRPr lang="en-US" sz="1400" dirty="0"/>
-          </a:p>
-        </p:txBody>
-      </p:sp>
-      <p:sp>
-        <p:nvSpPr>
-          <p:cNvPr id="11" name="badge"/>
-          <p:cNvSpPr/>
-          <p:nvPr/>
-        </p:nvSpPr>
-        <p:spPr>
-          <a:xfrm>
-            <a:off x="457200" y="2926080"/>
-            <a:ext cx="548640" cy="548640"/>
-          </a:xfrm>
-          <a:prstGeom prst="ellipse">
-            <a:avLst/>
-          </a:prstGeom>
-          <a:solidFill>
-            <a:schemeClr val="accent2"/>
-          </a:solidFill>
-          <a:ln w="12700">
-            <a:solidFill>
-              <a:schemeClr val="accent2"/>
-            </a:solidFill>
-            <a:prstDash val="solid"/>
-          </a:ln>
-        </p:spPr>
-      </p:sp>
-      <p:pic>
-        <p:nvPicPr>
-          <p:cNvPr id="12" name="icono" descr="preencoded.png">    </p:cNvPr>
-          <p:cNvPicPr>
-            <a:picLocks noChangeAspect="1"/>
-          </p:cNvPicPr>
-          <p:nvPr/>
-        </p:nvPicPr>
-        <p:blipFill>
-          <a:blip r:embed="rId3"/>
-          <a:stretch>
-            <a:fillRect/>
-          </a:stretch>
-        </p:blipFill>
-        <p:spPr>
-          <a:xfrm>
-            <a:off x="577901" y="3046781"/>
-            <a:ext cx="307238" cy="307238"/>
-          </a:xfrm>
-          <a:prstGeom prst="rect">
-            <a:avLst/>
-          </a:prstGeom>
-        </p:spPr>
-      </p:pic>
-      <p:sp>
-        <p:nvSpPr>
-          <p:cNvPr id="13" name="Text 8"/>
-          <p:cNvSpPr txBox="1"/>
-          <p:nvPr/>
-        </p:nvSpPr>
-        <p:spPr>
-          <a:xfrm>
-            <a:off x="1188720" y="2880360"/>
-            <a:ext cx="3200400" cy="365760"/>
-          </a:xfrm>
-          <a:prstGeom prst="rect">
-            <a:avLst/>
-          </a:prstGeom>
-          <a:noFill/>
-          <a:ln/>
-        </p:spPr>
-        <p:txBody>
-          <a:bodyPr wrap="square" lIns="0" tIns="0" rIns="0" bIns="0" rtlCol="0" anchor="t"/>
-          <a:lstStyle/>
-          <a:p>
-            <a:pPr indent="0" marL="0">
-              <a:buNone/>
-            </a:pPr>
-            <a:r>
-              <a:rPr lang="en-US" sz="1600" b="1" dirty="0">
-                <a:solidFill>
-                  <a:schemeClr val="tx1"/>
-                </a:solidFill>
-              </a:rPr>
-              <a:t>Ahorro de tiempo no cronometrado</a:t>
-            </a:r>
-            <a:endParaRPr lang="en-US" sz="1600" dirty="0"/>
-          </a:p>
-        </p:txBody>
-      </p:sp>
-      <p:sp>
-        <p:nvSpPr>
-          <p:cNvPr id="14" name="Text 9"/>
-          <p:cNvSpPr txBox="1"/>
-          <p:nvPr/>
-        </p:nvSpPr>
-        <p:spPr>
-          <a:xfrm>
-            <a:off x="1188720" y="3291840"/>
-            <a:ext cx="3200400" cy="822960"/>
-          </a:xfrm>
-          <a:prstGeom prst="rect">
-            <a:avLst/>
-          </a:prstGeom>
-          <a:noFill/>
-          <a:ln/>
-        </p:spPr>
-        <p:txBody>
-          <a:bodyPr wrap="square" lIns="0" tIns="0" rIns="0" bIns="0" rtlCol="0" anchor="t"/>
-          <a:lstStyle/>
-          <a:p>
-            <a:pPr indent="0" marL="0">
-              <a:buNone/>
-            </a:pPr>
-            <a:r>
-              <a:rPr lang="en-US" sz="1400" dirty="0">
-                <a:solidFill>
-                  <a:schemeClr val="tx2"/>
-                </a:solidFill>
-              </a:rPr>
-              <a:t>Se midió el cálculo (ms), no el flujo completo en SAP2000</a:t>
-            </a:r>
-            <a:endParaRPr lang="en-US" sz="1400" dirty="0"/>
-          </a:p>
-        </p:txBody>
-      </p:sp>
-      <p:sp>
-        <p:nvSpPr>
-          <p:cNvPr id="15" name="badge"/>
-          <p:cNvSpPr/>
-          <p:nvPr/>
-        </p:nvSpPr>
-        <p:spPr>
-          <a:xfrm>
-            <a:off x="4663440" y="2926080"/>
-            <a:ext cx="548640" cy="548640"/>
-          </a:xfrm>
-          <a:prstGeom prst="ellipse">
-            <a:avLst/>
-          </a:prstGeom>
-          <a:solidFill>
-            <a:schemeClr val="accent2"/>
-          </a:solidFill>
-          <a:ln w="12700">
-            <a:solidFill>
-              <a:schemeClr val="accent2"/>
-            </a:solidFill>
-            <a:prstDash val="solid"/>
-          </a:ln>
-        </p:spPr>
-      </p:sp>
-      <p:pic>
-        <p:nvPicPr>
-          <p:cNvPr id="16" name="icono" descr="preencoded.png">    </p:cNvPr>
-          <p:cNvPicPr>
-            <a:picLocks noChangeAspect="1"/>
-          </p:cNvPicPr>
-          <p:nvPr/>
-        </p:nvPicPr>
-        <p:blipFill>
-          <a:blip r:embed="rId4"/>
-          <a:stretch>
-            <a:fillRect/>
-          </a:stretch>
-        </p:blipFill>
-        <p:spPr>
-          <a:xfrm>
-            <a:off x="4784141" y="3046781"/>
-            <a:ext cx="307238" cy="307238"/>
-          </a:xfrm>
-          <a:prstGeom prst="rect">
-            <a:avLst/>
-          </a:prstGeom>
-        </p:spPr>
-      </p:pic>
-      <p:sp>
-        <p:nvSpPr>
-          <p:cNvPr id="17" name="Text 11"/>
-          <p:cNvSpPr txBox="1"/>
-          <p:nvPr/>
-        </p:nvSpPr>
-        <p:spPr>
-          <a:xfrm>
-            <a:off x="5394960" y="2880360"/>
-            <a:ext cx="3200400" cy="365760"/>
-          </a:xfrm>
-          <a:prstGeom prst="rect">
-            <a:avLst/>
-          </a:prstGeom>
-          <a:noFill/>
-          <a:ln/>
-        </p:spPr>
-        <p:txBody>
-          <a:bodyPr wrap="square" lIns="0" tIns="0" rIns="0" bIns="0" rtlCol="0" anchor="t"/>
-          <a:lstStyle/>
-          <a:p>
-            <a:pPr indent="0" marL="0">
-              <a:buNone/>
-            </a:pPr>
-            <a:r>
-              <a:rPr lang="en-US" sz="1600" b="1" dirty="0">
-                <a:solidFill>
-                  <a:schemeClr val="tx1"/>
-                </a:solidFill>
-              </a:rPr>
-              <a:t>Bot sin backend conectado</a:t>
-            </a:r>
-            <a:endParaRPr lang="en-US" sz="1600" dirty="0"/>
-          </a:p>
-        </p:txBody>
-      </p:sp>
-      <p:sp>
-        <p:nvSpPr>
-          <p:cNvPr id="18" name="Text 12"/>
-          <p:cNvSpPr txBox="1"/>
-          <p:nvPr/>
-        </p:nvSpPr>
-        <p:spPr>
-          <a:xfrm>
-            <a:off x="5394960" y="3291840"/>
-            <a:ext cx="3200400" cy="822960"/>
-          </a:xfrm>
-          <a:prstGeom prst="rect">
-            <a:avLst/>
-          </a:prstGeom>
-          <a:noFill/>
-          <a:ln/>
-        </p:spPr>
-        <p:txBody>
-          <a:bodyPr wrap="square" lIns="0" tIns="0" rIns="0" bIns="0" rtlCol="0" anchor="t"/>
-          <a:lstStyle/>
-          <a:p>
-            <a:pPr indent="0" marL="0">
-              <a:buNone/>
-            </a:pPr>
-            <a:r>
-              <a:rPr lang="en-US" sz="1400" dirty="0">
-                <a:solidFill>
-                  <a:schemeClr val="tx2"/>
-                </a:solidFill>
-              </a:rPr>
-              <a:t>Los flujos de n8n esperan el servicio Python con el predictor</a:t>
+              <a:t>falsas alarmas; el modelo subestima los casos más cercanos al límite</a:t>
             </a:r>
             <a:endParaRPr lang="en-US" sz="1400" dirty="0"/>
           </a:p>
@@ -4440,13 +4419,13 @@
             <a:r>
               <a:rPr lang="en-US" sz="2800" b="1" dirty="0">
                 <a:solidFill>
-                  <a:schemeClr val="bg1"/>
+                  <a:schemeClr val="tx1"/>
                 </a:solidFill>
                 <a:latin typeface="Cambria" pitchFamily="34" charset="0"/>
                 <a:ea typeface="Cambria" pitchFamily="34" charset="-122"/>
                 <a:cs typeface="Cambria" pitchFamily="34" charset="-120"/>
               </a:rPr>
-              <a:t>Conclusiones y siguientes pasos</a:t>
+              <a:t>Limitaciones que condicionan los resultados</a:t>
             </a:r>
             <a:endParaRPr lang="en-US" sz="2800" dirty="0"/>
           </a:p>
@@ -4454,60 +4433,120 @@
       </p:sp>
       <p:sp>
         <p:nvSpPr>
-          <p:cNvPr id="3" name="numero"/>
+          <p:cNvPr id="3" name="badge"/>
           <p:cNvSpPr/>
           <p:nvPr/>
         </p:nvSpPr>
         <p:spPr>
           <a:xfrm>
-            <a:off x="457200" y="1188720"/>
-            <a:ext cx="384048" cy="384048"/>
+            <a:off x="457200" y="1280160"/>
+            <a:ext cx="548640" cy="548640"/>
           </a:xfrm>
           <a:prstGeom prst="ellipse">
             <a:avLst/>
           </a:prstGeom>
           <a:solidFill>
-            <a:schemeClr val="accent1"/>
+            <a:schemeClr val="accent2"/>
           </a:solidFill>
           <a:ln w="12700">
             <a:solidFill>
-              <a:schemeClr val="accent1"/>
+              <a:schemeClr val="accent2"/>
             </a:solidFill>
             <a:prstDash val="solid"/>
           </a:ln>
         </p:spPr>
       </p:sp>
-      <p:sp>
-        <p:nvSpPr>
-          <p:cNvPr id="4" name="Text 2"/>
+      <p:pic>
+        <p:nvPicPr>
+          <p:cNvPr id="4" name="icono" descr="preencoded.png">    </p:cNvPr>
+          <p:cNvPicPr>
+            <a:picLocks noChangeAspect="1"/>
+          </p:cNvPicPr>
+          <p:nvPr/>
+        </p:nvPicPr>
+        <p:blipFill>
+          <a:blip r:embed="rId1"/>
+          <a:stretch>
+            <a:fillRect/>
+          </a:stretch>
+        </p:blipFill>
+        <p:spPr>
+          <a:xfrm>
+            <a:off x="577901" y="1400861"/>
+            <a:ext cx="307238" cy="307238"/>
+          </a:xfrm>
+          <a:prstGeom prst="rect">
+            <a:avLst/>
+          </a:prstGeom>
+        </p:spPr>
+      </p:pic>
+      <p:sp>
+        <p:nvSpPr>
+          <p:cNvPr id="5" name="Text 2"/>
           <p:cNvSpPr txBox="1"/>
           <p:nvPr/>
         </p:nvSpPr>
         <p:spPr>
           <a:xfrm>
-            <a:off x="457200" y="1188720"/>
-            <a:ext cx="384048" cy="384048"/>
-          </a:xfrm>
-          <a:prstGeom prst="rect">
-            <a:avLst/>
-          </a:prstGeom>
-          <a:noFill/>
-          <a:ln/>
-        </p:spPr>
-        <p:txBody>
-          <a:bodyPr wrap="square" lIns="0" tIns="0" rIns="0" bIns="0" rtlCol="0" anchor="ctr"/>
-          <a:lstStyle/>
-          <a:p>
-            <a:pPr algn="ctr" indent="0" marL="0">
-              <a:buNone/>
-            </a:pPr>
-            <a:r>
-              <a:rPr lang="en-US" sz="1400" b="1" dirty="0">
-                <a:solidFill>
-                  <a:schemeClr val="bg1"/>
-                </a:solidFill>
-              </a:rPr>
-              <a:t>1</a:t>
+            <a:off x="1188720" y="1234440"/>
+            <a:ext cx="3200400" cy="365760"/>
+          </a:xfrm>
+          <a:prstGeom prst="rect">
+            <a:avLst/>
+          </a:prstGeom>
+          <a:noFill/>
+          <a:ln/>
+        </p:spPr>
+        <p:txBody>
+          <a:bodyPr wrap="square" lIns="0" tIns="0" rIns="0" bIns="0" rtlCol="0" anchor="t"/>
+          <a:lstStyle/>
+          <a:p>
+            <a:pPr indent="0" marL="0">
+              <a:buNone/>
+            </a:pPr>
+            <a:r>
+              <a:rPr lang="en-US" sz="1600" b="1" dirty="0">
+                <a:solidFill>
+                  <a:schemeClr val="tx1"/>
+                </a:solidFill>
+              </a:rPr>
+              <a:t>Base NSR-10 pequeña y teórica</a:t>
+            </a:r>
+            <a:endParaRPr lang="en-US" sz="1600" dirty="0"/>
+          </a:p>
+        </p:txBody>
+      </p:sp>
+      <p:sp>
+        <p:nvSpPr>
+          <p:cNvPr id="6" name="Text 3"/>
+          <p:cNvSpPr txBox="1"/>
+          <p:nvPr/>
+        </p:nvSpPr>
+        <p:spPr>
+          <a:xfrm>
+            <a:off x="1188720" y="1645920"/>
+            <a:ext cx="3200400" cy="822960"/>
+          </a:xfrm>
+          <a:prstGeom prst="rect">
+            <a:avLst/>
+          </a:prstGeom>
+          <a:noFill/>
+          <a:ln/>
+        </p:spPr>
+        <p:txBody>
+          <a:bodyPr wrap="square" lIns="0" tIns="0" rIns="0" bIns="0" rtlCol="0" anchor="t"/>
+          <a:lstStyle/>
+          <a:p>
+            <a:pPr indent="0" marL="0">
+              <a:buNone/>
+            </a:pPr>
+            <a:r>
+              <a:rPr lang="en-US" sz="1400" dirty="0">
+                <a:solidFill>
+                  <a:schemeClr val="tx2"/>
+                </a:solidFill>
+              </a:rPr>
+              <a:t>18 edificios; varias configuraciones no serían viables en pórticos reales</a:t>
             </a:r>
             <a:endParaRPr lang="en-US" sz="1400" dirty="0"/>
           </a:p>
@@ -4515,96 +4554,120 @@
       </p:sp>
       <p:sp>
         <p:nvSpPr>
-          <p:cNvPr id="5" name="Text 3"/>
-          <p:cNvSpPr txBox="1"/>
-          <p:nvPr/>
-        </p:nvSpPr>
-        <p:spPr>
-          <a:xfrm>
-            <a:off x="1005840" y="1161288"/>
-            <a:ext cx="3931920" cy="777240"/>
-          </a:xfrm>
-          <a:prstGeom prst="rect">
-            <a:avLst/>
-          </a:prstGeom>
-          <a:noFill/>
-          <a:ln/>
-        </p:spPr>
-        <p:txBody>
-          <a:bodyPr wrap="square" lIns="0" tIns="0" rIns="0" bIns="0" rtlCol="0" anchor="t"/>
-          <a:lstStyle/>
-          <a:p>
-            <a:pPr indent="0" marL="0">
-              <a:buNone/>
-            </a:pPr>
-            <a:r>
-              <a:rPr lang="en-US" sz="1400" dirty="0">
-                <a:solidFill>
-                  <a:schemeClr val="bg1"/>
-                </a:solidFill>
-              </a:rPr>
-              <a:t>El módulo NSR-10 reproduce el cálculo de referencia y bloquea datos incompletos o erróneos antes de calcular.</a:t>
-            </a:r>
-            <a:endParaRPr lang="en-US" sz="1400" dirty="0"/>
-          </a:p>
-        </p:txBody>
-      </p:sp>
-      <p:sp>
-        <p:nvSpPr>
-          <p:cNvPr id="6" name="numero"/>
+          <p:cNvPr id="7" name="badge"/>
           <p:cNvSpPr/>
           <p:nvPr/>
         </p:nvSpPr>
         <p:spPr>
           <a:xfrm>
-            <a:off x="457200" y="2057400"/>
-            <a:ext cx="384048" cy="384048"/>
+            <a:off x="4663440" y="1280160"/>
+            <a:ext cx="548640" cy="548640"/>
           </a:xfrm>
           <a:prstGeom prst="ellipse">
             <a:avLst/>
           </a:prstGeom>
           <a:solidFill>
-            <a:schemeClr val="accent1"/>
+            <a:schemeClr val="accent2"/>
           </a:solidFill>
           <a:ln w="12700">
             <a:solidFill>
-              <a:schemeClr val="accent1"/>
+              <a:schemeClr val="accent2"/>
             </a:solidFill>
             <a:prstDash val="solid"/>
           </a:ln>
         </p:spPr>
       </p:sp>
-      <p:sp>
-        <p:nvSpPr>
-          <p:cNvPr id="7" name="Text 5"/>
+      <p:pic>
+        <p:nvPicPr>
+          <p:cNvPr id="8" name="icono" descr="preencoded.png">    </p:cNvPr>
+          <p:cNvPicPr>
+            <a:picLocks noChangeAspect="1"/>
+          </p:cNvPicPr>
+          <p:nvPr/>
+        </p:nvPicPr>
+        <p:blipFill>
+          <a:blip r:embed="rId2"/>
+          <a:stretch>
+            <a:fillRect/>
+          </a:stretch>
+        </p:blipFill>
+        <p:spPr>
+          <a:xfrm>
+            <a:off x="4784141" y="1400861"/>
+            <a:ext cx="307238" cy="307238"/>
+          </a:xfrm>
+          <a:prstGeom prst="rect">
+            <a:avLst/>
+          </a:prstGeom>
+        </p:spPr>
+      </p:pic>
+      <p:sp>
+        <p:nvSpPr>
+          <p:cNvPr id="9" name="Text 5"/>
           <p:cNvSpPr txBox="1"/>
           <p:nvPr/>
         </p:nvSpPr>
         <p:spPr>
           <a:xfrm>
-            <a:off x="457200" y="2057400"/>
-            <a:ext cx="384048" cy="384048"/>
-          </a:xfrm>
-          <a:prstGeom prst="rect">
-            <a:avLst/>
-          </a:prstGeom>
-          <a:noFill/>
-          <a:ln/>
-        </p:spPr>
-        <p:txBody>
-          <a:bodyPr wrap="square" lIns="0" tIns="0" rIns="0" bIns="0" rtlCol="0" anchor="ctr"/>
-          <a:lstStyle/>
-          <a:p>
-            <a:pPr algn="ctr" indent="0" marL="0">
-              <a:buNone/>
-            </a:pPr>
-            <a:r>
-              <a:rPr lang="en-US" sz="1400" b="1" dirty="0">
-                <a:solidFill>
-                  <a:schemeClr val="bg1"/>
-                </a:solidFill>
-              </a:rPr>
-              <a:t>2</a:t>
+            <a:off x="5394960" y="1234440"/>
+            <a:ext cx="3200400" cy="365760"/>
+          </a:xfrm>
+          <a:prstGeom prst="rect">
+            <a:avLst/>
+          </a:prstGeom>
+          <a:noFill/>
+          <a:ln/>
+        </p:spPr>
+        <p:txBody>
+          <a:bodyPr wrap="square" lIns="0" tIns="0" rIns="0" bIns="0" rtlCol="0" anchor="t"/>
+          <a:lstStyle/>
+          <a:p>
+            <a:pPr indent="0" marL="0">
+              <a:buNone/>
+            </a:pPr>
+            <a:r>
+              <a:rPr lang="en-US" sz="1600" b="1" dirty="0">
+                <a:solidFill>
+                  <a:schemeClr val="tx1"/>
+                </a:solidFill>
+              </a:rPr>
+              <a:t>Dominio E.030 acotado</a:t>
+            </a:r>
+            <a:endParaRPr lang="en-US" sz="1600" dirty="0"/>
+          </a:p>
+        </p:txBody>
+      </p:sp>
+      <p:sp>
+        <p:nvSpPr>
+          <p:cNvPr id="10" name="Text 6"/>
+          <p:cNvSpPr txBox="1"/>
+          <p:nvPr/>
+        </p:nvSpPr>
+        <p:spPr>
+          <a:xfrm>
+            <a:off x="5394960" y="1645920"/>
+            <a:ext cx="3200400" cy="822960"/>
+          </a:xfrm>
+          <a:prstGeom prst="rect">
+            <a:avLst/>
+          </a:prstGeom>
+          <a:noFill/>
+          <a:ln/>
+        </p:spPr>
+        <p:txBody>
+          <a:bodyPr wrap="square" lIns="0" tIns="0" rIns="0" bIns="0" rtlCol="0" anchor="t"/>
+          <a:lstStyle/>
+          <a:p>
+            <a:pPr indent="0" marL="0">
+              <a:buNone/>
+            </a:pPr>
+            <a:r>
+              <a:rPr lang="en-US" sz="1400" dirty="0">
+                <a:solidFill>
+                  <a:schemeClr val="tx2"/>
+                </a:solidFill>
+              </a:rPr>
+              <a:t>2 a 5 pisos, secciones brutas, sin P-Delta; el modelo no extrapola fuera de ese rango</a:t>
             </a:r>
             <a:endParaRPr lang="en-US" sz="1400" dirty="0"/>
           </a:p>
@@ -4612,96 +4675,120 @@
       </p:sp>
       <p:sp>
         <p:nvSpPr>
-          <p:cNvPr id="8" name="Text 6"/>
-          <p:cNvSpPr txBox="1"/>
-          <p:nvPr/>
-        </p:nvSpPr>
-        <p:spPr>
-          <a:xfrm>
-            <a:off x="1005840" y="2029968"/>
-            <a:ext cx="3931920" cy="777240"/>
-          </a:xfrm>
-          <a:prstGeom prst="rect">
-            <a:avLst/>
-          </a:prstGeom>
-          <a:noFill/>
-          <a:ln/>
-        </p:spPr>
-        <p:txBody>
-          <a:bodyPr wrap="square" lIns="0" tIns="0" rIns="0" bIns="0" rtlCol="0" anchor="t"/>
-          <a:lstStyle/>
-          <a:p>
-            <a:pPr indent="0" marL="0">
-              <a:buNone/>
-            </a:pPr>
-            <a:r>
-              <a:rPr lang="en-US" sz="1400" dirty="0">
-                <a:solidFill>
-                  <a:schemeClr val="bg1"/>
-                </a:solidFill>
-              </a:rPr>
-              <a:t>En plantas no vistas, Random Forest estimó la deriva con 0,086 % (X) y 0,101 % (Y) de error: 39 % menos que la referencia.</a:t>
-            </a:r>
-            <a:endParaRPr lang="en-US" sz="1400" dirty="0"/>
-          </a:p>
-        </p:txBody>
-      </p:sp>
-      <p:sp>
-        <p:nvSpPr>
-          <p:cNvPr id="9" name="numero"/>
+          <p:cNvPr id="11" name="badge"/>
           <p:cNvSpPr/>
           <p:nvPr/>
         </p:nvSpPr>
         <p:spPr>
           <a:xfrm>
             <a:off x="457200" y="2926080"/>
-            <a:ext cx="384048" cy="384048"/>
+            <a:ext cx="548640" cy="548640"/>
           </a:xfrm>
           <a:prstGeom prst="ellipse">
             <a:avLst/>
           </a:prstGeom>
           <a:solidFill>
-            <a:schemeClr val="accent1"/>
+            <a:schemeClr val="accent2"/>
           </a:solidFill>
           <a:ln w="12700">
             <a:solidFill>
-              <a:schemeClr val="accent1"/>
+              <a:schemeClr val="accent2"/>
             </a:solidFill>
             <a:prstDash val="solid"/>
           </a:ln>
         </p:spPr>
       </p:sp>
-      <p:sp>
-        <p:nvSpPr>
-          <p:cNvPr id="10" name="Text 8"/>
+      <p:pic>
+        <p:nvPicPr>
+          <p:cNvPr id="12" name="icono" descr="preencoded.png">    </p:cNvPr>
+          <p:cNvPicPr>
+            <a:picLocks noChangeAspect="1"/>
+          </p:cNvPicPr>
+          <p:nvPr/>
+        </p:nvPicPr>
+        <p:blipFill>
+          <a:blip r:embed="rId3"/>
+          <a:stretch>
+            <a:fillRect/>
+          </a:stretch>
+        </p:blipFill>
+        <p:spPr>
+          <a:xfrm>
+            <a:off x="577901" y="3046781"/>
+            <a:ext cx="307238" cy="307238"/>
+          </a:xfrm>
+          <a:prstGeom prst="rect">
+            <a:avLst/>
+          </a:prstGeom>
+        </p:spPr>
+      </p:pic>
+      <p:sp>
+        <p:nvSpPr>
+          <p:cNvPr id="13" name="Text 8"/>
           <p:cNvSpPr txBox="1"/>
           <p:nvPr/>
         </p:nvSpPr>
         <p:spPr>
           <a:xfrm>
-            <a:off x="457200" y="2926080"/>
-            <a:ext cx="384048" cy="384048"/>
-          </a:xfrm>
-          <a:prstGeom prst="rect">
-            <a:avLst/>
-          </a:prstGeom>
-          <a:noFill/>
-          <a:ln/>
-        </p:spPr>
-        <p:txBody>
-          <a:bodyPr wrap="square" lIns="0" tIns="0" rIns="0" bIns="0" rtlCol="0" anchor="ctr"/>
-          <a:lstStyle/>
-          <a:p>
-            <a:pPr algn="ctr" indent="0" marL="0">
-              <a:buNone/>
-            </a:pPr>
-            <a:r>
-              <a:rPr lang="en-US" sz="1400" b="1" dirty="0">
-                <a:solidFill>
-                  <a:schemeClr val="bg1"/>
-                </a:solidFill>
-              </a:rPr>
-              <a:t>3</a:t>
+            <a:off x="1188720" y="2880360"/>
+            <a:ext cx="3200400" cy="365760"/>
+          </a:xfrm>
+          <a:prstGeom prst="rect">
+            <a:avLst/>
+          </a:prstGeom>
+          <a:noFill/>
+          <a:ln/>
+        </p:spPr>
+        <p:txBody>
+          <a:bodyPr wrap="square" lIns="0" tIns="0" rIns="0" bIns="0" rtlCol="0" anchor="t"/>
+          <a:lstStyle/>
+          <a:p>
+            <a:pPr indent="0" marL="0">
+              <a:buNone/>
+            </a:pPr>
+            <a:r>
+              <a:rPr lang="en-US" sz="1600" b="1" dirty="0">
+                <a:solidFill>
+                  <a:schemeClr val="tx1"/>
+                </a:solidFill>
+              </a:rPr>
+              <a:t>Ahorro de tiempo no cronometrado</a:t>
+            </a:r>
+            <a:endParaRPr lang="en-US" sz="1600" dirty="0"/>
+          </a:p>
+        </p:txBody>
+      </p:sp>
+      <p:sp>
+        <p:nvSpPr>
+          <p:cNvPr id="14" name="Text 9"/>
+          <p:cNvSpPr txBox="1"/>
+          <p:nvPr/>
+        </p:nvSpPr>
+        <p:spPr>
+          <a:xfrm>
+            <a:off x="1188720" y="3291840"/>
+            <a:ext cx="3200400" cy="822960"/>
+          </a:xfrm>
+          <a:prstGeom prst="rect">
+            <a:avLst/>
+          </a:prstGeom>
+          <a:noFill/>
+          <a:ln/>
+        </p:spPr>
+        <p:txBody>
+          <a:bodyPr wrap="square" lIns="0" tIns="0" rIns="0" bIns="0" rtlCol="0" anchor="t"/>
+          <a:lstStyle/>
+          <a:p>
+            <a:pPr indent="0" marL="0">
+              <a:buNone/>
+            </a:pPr>
+            <a:r>
+              <a:rPr lang="en-US" sz="1400" dirty="0">
+                <a:solidFill>
+                  <a:schemeClr val="tx2"/>
+                </a:solidFill>
+              </a:rPr>
+              <a:t>Se midió el cálculo (ms), no el flujo completo en SAP2000</a:t>
             </a:r>
             <a:endParaRPr lang="en-US" sz="1400" dirty="0"/>
           </a:p>
@@ -4709,77 +4796,63 @@
       </p:sp>
       <p:sp>
         <p:nvSpPr>
-          <p:cNvPr id="11" name="Text 9"/>
-          <p:cNvSpPr txBox="1"/>
-          <p:nvPr/>
-        </p:nvSpPr>
-        <p:spPr>
-          <a:xfrm>
-            <a:off x="1005840" y="2898648"/>
-            <a:ext cx="3931920" cy="777240"/>
-          </a:xfrm>
-          <a:prstGeom prst="rect">
-            <a:avLst/>
-          </a:prstGeom>
-          <a:noFill/>
-          <a:ln/>
-        </p:spPr>
-        <p:txBody>
-          <a:bodyPr wrap="square" lIns="0" tIns="0" rIns="0" bIns="0" rtlCol="0" anchor="t"/>
-          <a:lstStyle/>
-          <a:p>
-            <a:pPr indent="0" marL="0">
-              <a:buNone/>
-            </a:pPr>
-            <a:r>
-              <a:rPr lang="en-US" sz="1400" dirty="0">
-                <a:solidFill>
-                  <a:schemeClr val="bg1"/>
-                </a:solidFill>
-              </a:rPr>
-              <a:t>Detecta 3 de 7 edificios cerca del límite: útil para priorizar, no para certificar.</a:t>
-            </a:r>
-            <a:endParaRPr lang="en-US" sz="1400" dirty="0"/>
-          </a:p>
-        </p:txBody>
-      </p:sp>
-      <p:sp>
-        <p:nvSpPr>
-          <p:cNvPr id="12" name="siguientes"/>
+          <p:cNvPr id="15" name="badge"/>
           <p:cNvSpPr/>
           <p:nvPr/>
         </p:nvSpPr>
         <p:spPr>
           <a:xfrm>
-            <a:off x="5303520" y="1143000"/>
-            <a:ext cx="3383280" cy="3291840"/>
-          </a:xfrm>
-          <a:prstGeom prst="roundRect">
-            <a:avLst>
-              <a:gd name="adj" fmla="val 2222"/>
-            </a:avLst>
+            <a:off x="4663440" y="2926080"/>
+            <a:ext cx="548640" cy="548640"/>
+          </a:xfrm>
+          <a:prstGeom prst="ellipse">
+            <a:avLst/>
           </a:prstGeom>
           <a:solidFill>
-            <a:srgbClr val="3A4A57"/>
+            <a:schemeClr val="accent2"/>
           </a:solidFill>
           <a:ln w="12700">
             <a:solidFill>
-              <a:srgbClr val="3A4A57"/>
+              <a:schemeClr val="accent2"/>
             </a:solidFill>
             <a:prstDash val="solid"/>
           </a:ln>
         </p:spPr>
       </p:sp>
-      <p:sp>
-        <p:nvSpPr>
-          <p:cNvPr id="13" name="Text 11"/>
+      <p:pic>
+        <p:nvPicPr>
+          <p:cNvPr id="16" name="icono" descr="preencoded.png">    </p:cNvPr>
+          <p:cNvPicPr>
+            <a:picLocks noChangeAspect="1"/>
+          </p:cNvPicPr>
+          <p:nvPr/>
+        </p:nvPicPr>
+        <p:blipFill>
+          <a:blip r:embed="rId4"/>
+          <a:stretch>
+            <a:fillRect/>
+          </a:stretch>
+        </p:blipFill>
+        <p:spPr>
+          <a:xfrm>
+            <a:off x="4784141" y="3046781"/>
+            <a:ext cx="307238" cy="307238"/>
+          </a:xfrm>
+          <a:prstGeom prst="rect">
+            <a:avLst/>
+          </a:prstGeom>
+        </p:spPr>
+      </p:pic>
+      <p:sp>
+        <p:nvSpPr>
+          <p:cNvPr id="17" name="Text 11"/>
           <p:cNvSpPr txBox="1"/>
           <p:nvPr/>
         </p:nvSpPr>
         <p:spPr>
           <a:xfrm>
-            <a:off x="5532120" y="1280160"/>
-            <a:ext cx="3017520" cy="365760"/>
+            <a:off x="5394960" y="2880360"/>
+            <a:ext cx="3200400" cy="365760"/>
           </a:xfrm>
           <a:prstGeom prst="rect">
             <a:avLst/>
@@ -4795,27 +4868,27 @@
               <a:buNone/>
             </a:pPr>
             <a:r>
-              <a:rPr lang="en-US" sz="1700" b="1" dirty="0">
-                <a:solidFill>
-                  <a:schemeClr val="accent1"/>
-                </a:solidFill>
-              </a:rPr>
-              <a:t>Siguientes pasos</a:t>
-            </a:r>
-            <a:endParaRPr lang="en-US" sz="1700" dirty="0"/>
-          </a:p>
-        </p:txBody>
-      </p:sp>
-      <p:sp>
-        <p:nvSpPr>
-          <p:cNvPr id="14" name="Text 12"/>
+              <a:rPr lang="en-US" sz="1600" b="1" dirty="0">
+                <a:solidFill>
+                  <a:schemeClr val="tx1"/>
+                </a:solidFill>
+              </a:rPr>
+              <a:t>Bot sin backend conectado</a:t>
+            </a:r>
+            <a:endParaRPr lang="en-US" sz="1600" dirty="0"/>
+          </a:p>
+        </p:txBody>
+      </p:sp>
+      <p:sp>
+        <p:nvSpPr>
+          <p:cNvPr id="18" name="Text 12"/>
           <p:cNvSpPr txBox="1"/>
           <p:nvPr/>
         </p:nvSpPr>
         <p:spPr>
           <a:xfrm>
-            <a:off x="5532120" y="1737360"/>
-            <a:ext cx="3017520" cy="2560320"/>
+            <a:off x="5394960" y="3291840"/>
+            <a:ext cx="3200400" cy="822960"/>
           </a:xfrm>
           <a:prstGeom prst="rect">
             <a:avLst/>
@@ -4827,74 +4900,16 @@
           <a:bodyPr wrap="square" lIns="0" tIns="0" rIns="0" bIns="0" rtlCol="0" anchor="t"/>
           <a:lstStyle/>
           <a:p>
-            <a:pPr marL="342900" indent="-342900">
-              <a:spcAft>
-                <a:spcPts val="600"/>
-              </a:spcAft>
-              <a:buSzPct val="100000"/>
-              <a:buChar char="•"/>
+            <a:pPr indent="0" marL="0">
+              <a:buNone/>
             </a:pPr>
             <a:r>
               <a:rPr lang="en-US" sz="1400" dirty="0">
                 <a:solidFill>
-                  <a:schemeClr val="bg1"/>
-                </a:solidFill>
-              </a:rPr>
-              <a:t>Evaluar el modelo en las familias E.030 reservadas</a:t>
-            </a:r>
-            <a:endParaRPr lang="en-US" sz="1400" dirty="0"/>
-          </a:p>
-          <a:p>
-            <a:pPr marL="342900" indent="-342900">
-              <a:spcAft>
-                <a:spcPts val="600"/>
-              </a:spcAft>
-              <a:buSzPct val="100000"/>
-              <a:buChar char="•"/>
-            </a:pPr>
-            <a:r>
-              <a:rPr lang="en-US" sz="1400" dirty="0">
-                <a:solidFill>
-                  <a:schemeClr val="bg1"/>
-                </a:solidFill>
-              </a:rPr>
-              <a:t>Ampliar la base NSR-10 con casos verificados</a:t>
-            </a:r>
-            <a:endParaRPr lang="en-US" sz="1400" dirty="0"/>
-          </a:p>
-          <a:p>
-            <a:pPr marL="342900" indent="-342900">
-              <a:spcAft>
-                <a:spcPts val="600"/>
-              </a:spcAft>
-              <a:buSzPct val="100000"/>
-              <a:buChar char="•"/>
-            </a:pPr>
-            <a:r>
-              <a:rPr lang="en-US" sz="1400" dirty="0">
-                <a:solidFill>
-                  <a:schemeClr val="bg1"/>
-                </a:solidFill>
-              </a:rPr>
-              <a:t>Conectar módulo y predictor al bot de Telegram</a:t>
-            </a:r>
-            <a:endParaRPr lang="en-US" sz="1400" dirty="0"/>
-          </a:p>
-          <a:p>
-            <a:pPr marL="342900" indent="-342900">
-              <a:spcAft>
-                <a:spcPts val="600"/>
-              </a:spcAft>
-              <a:buSzPct val="100000"/>
-              <a:buChar char="•"/>
-            </a:pPr>
-            <a:r>
-              <a:rPr lang="en-US" sz="1400" dirty="0">
-                <a:solidFill>
-                  <a:schemeClr val="bg1"/>
-                </a:solidFill>
-              </a:rPr>
-              <a:t>Cronometrar el flujo completo para medir el ahorro</a:t>
+                  <a:schemeClr val="tx2"/>
+                </a:solidFill>
+              </a:rPr>
+              <a:t>Los flujos de n8n esperan el servicio Python con el predictor</a:t>
             </a:r>
             <a:endParaRPr lang="en-US" sz="1400" dirty="0"/>
           </a:p>
@@ -4930,7 +4945,7 @@
             <a:lvl1pPr>
               <a:defRPr sz="900">
                 <a:solidFill>
-                  <a:schemeClr val="accent6"/>
+                  <a:schemeClr val="accent2"/>
                 </a:solidFill>
               </a:defRPr>
             </a:lvl1pPr>
@@ -4999,6 +5014,547 @@
             <a:r>
               <a:rPr lang="en-US" sz="2800" b="1" dirty="0">
                 <a:solidFill>
+                  <a:schemeClr val="bg1"/>
+                </a:solidFill>
+                <a:latin typeface="Cambria" pitchFamily="34" charset="0"/>
+                <a:ea typeface="Cambria" pitchFamily="34" charset="-122"/>
+                <a:cs typeface="Cambria" pitchFamily="34" charset="-120"/>
+              </a:rPr>
+              <a:t>Conclusiones y siguientes pasos</a:t>
+            </a:r>
+            <a:endParaRPr lang="en-US" sz="2800" dirty="0"/>
+          </a:p>
+        </p:txBody>
+      </p:sp>
+      <p:sp>
+        <p:nvSpPr>
+          <p:cNvPr id="3" name="numero"/>
+          <p:cNvSpPr/>
+          <p:nvPr/>
+        </p:nvSpPr>
+        <p:spPr>
+          <a:xfrm>
+            <a:off x="457200" y="1188720"/>
+            <a:ext cx="384048" cy="384048"/>
+          </a:xfrm>
+          <a:prstGeom prst="ellipse">
+            <a:avLst/>
+          </a:prstGeom>
+          <a:solidFill>
+            <a:schemeClr val="accent1"/>
+          </a:solidFill>
+          <a:ln w="12700">
+            <a:solidFill>
+              <a:schemeClr val="accent1"/>
+            </a:solidFill>
+            <a:prstDash val="solid"/>
+          </a:ln>
+        </p:spPr>
+      </p:sp>
+      <p:sp>
+        <p:nvSpPr>
+          <p:cNvPr id="4" name="Text 2"/>
+          <p:cNvSpPr txBox="1"/>
+          <p:nvPr/>
+        </p:nvSpPr>
+        <p:spPr>
+          <a:xfrm>
+            <a:off x="457200" y="1188720"/>
+            <a:ext cx="384048" cy="384048"/>
+          </a:xfrm>
+          <a:prstGeom prst="rect">
+            <a:avLst/>
+          </a:prstGeom>
+          <a:noFill/>
+          <a:ln/>
+        </p:spPr>
+        <p:txBody>
+          <a:bodyPr wrap="square" lIns="0" tIns="0" rIns="0" bIns="0" rtlCol="0" anchor="ctr"/>
+          <a:lstStyle/>
+          <a:p>
+            <a:pPr algn="ctr" indent="0" marL="0">
+              <a:buNone/>
+            </a:pPr>
+            <a:r>
+              <a:rPr lang="en-US" sz="1400" b="1" dirty="0">
+                <a:solidFill>
+                  <a:schemeClr val="bg1"/>
+                </a:solidFill>
+              </a:rPr>
+              <a:t>1</a:t>
+            </a:r>
+            <a:endParaRPr lang="en-US" sz="1400" dirty="0"/>
+          </a:p>
+        </p:txBody>
+      </p:sp>
+      <p:sp>
+        <p:nvSpPr>
+          <p:cNvPr id="5" name="Text 3"/>
+          <p:cNvSpPr txBox="1"/>
+          <p:nvPr/>
+        </p:nvSpPr>
+        <p:spPr>
+          <a:xfrm>
+            <a:off x="1005840" y="1161288"/>
+            <a:ext cx="3931920" cy="777240"/>
+          </a:xfrm>
+          <a:prstGeom prst="rect">
+            <a:avLst/>
+          </a:prstGeom>
+          <a:noFill/>
+          <a:ln/>
+        </p:spPr>
+        <p:txBody>
+          <a:bodyPr wrap="square" lIns="0" tIns="0" rIns="0" bIns="0" rtlCol="0" anchor="t"/>
+          <a:lstStyle/>
+          <a:p>
+            <a:pPr indent="0" marL="0">
+              <a:buNone/>
+            </a:pPr>
+            <a:r>
+              <a:rPr lang="en-US" sz="1400" dirty="0">
+                <a:solidFill>
+                  <a:schemeClr val="bg1"/>
+                </a:solidFill>
+              </a:rPr>
+              <a:t>El módulo NSR-10 reproduce el cálculo de referencia y bloquea datos incompletos o erróneos antes de calcular.</a:t>
+            </a:r>
+            <a:endParaRPr lang="en-US" sz="1400" dirty="0"/>
+          </a:p>
+        </p:txBody>
+      </p:sp>
+      <p:sp>
+        <p:nvSpPr>
+          <p:cNvPr id="6" name="numero"/>
+          <p:cNvSpPr/>
+          <p:nvPr/>
+        </p:nvSpPr>
+        <p:spPr>
+          <a:xfrm>
+            <a:off x="457200" y="2057400"/>
+            <a:ext cx="384048" cy="384048"/>
+          </a:xfrm>
+          <a:prstGeom prst="ellipse">
+            <a:avLst/>
+          </a:prstGeom>
+          <a:solidFill>
+            <a:schemeClr val="accent1"/>
+          </a:solidFill>
+          <a:ln w="12700">
+            <a:solidFill>
+              <a:schemeClr val="accent1"/>
+            </a:solidFill>
+            <a:prstDash val="solid"/>
+          </a:ln>
+        </p:spPr>
+      </p:sp>
+      <p:sp>
+        <p:nvSpPr>
+          <p:cNvPr id="7" name="Text 5"/>
+          <p:cNvSpPr txBox="1"/>
+          <p:nvPr/>
+        </p:nvSpPr>
+        <p:spPr>
+          <a:xfrm>
+            <a:off x="457200" y="2057400"/>
+            <a:ext cx="384048" cy="384048"/>
+          </a:xfrm>
+          <a:prstGeom prst="rect">
+            <a:avLst/>
+          </a:prstGeom>
+          <a:noFill/>
+          <a:ln/>
+        </p:spPr>
+        <p:txBody>
+          <a:bodyPr wrap="square" lIns="0" tIns="0" rIns="0" bIns="0" rtlCol="0" anchor="ctr"/>
+          <a:lstStyle/>
+          <a:p>
+            <a:pPr algn="ctr" indent="0" marL="0">
+              <a:buNone/>
+            </a:pPr>
+            <a:r>
+              <a:rPr lang="en-US" sz="1400" b="1" dirty="0">
+                <a:solidFill>
+                  <a:schemeClr val="bg1"/>
+                </a:solidFill>
+              </a:rPr>
+              <a:t>2</a:t>
+            </a:r>
+            <a:endParaRPr lang="en-US" sz="1400" dirty="0"/>
+          </a:p>
+        </p:txBody>
+      </p:sp>
+      <p:sp>
+        <p:nvSpPr>
+          <p:cNvPr id="8" name="Text 6"/>
+          <p:cNvSpPr txBox="1"/>
+          <p:nvPr/>
+        </p:nvSpPr>
+        <p:spPr>
+          <a:xfrm>
+            <a:off x="1005840" y="2029968"/>
+            <a:ext cx="3931920" cy="777240"/>
+          </a:xfrm>
+          <a:prstGeom prst="rect">
+            <a:avLst/>
+          </a:prstGeom>
+          <a:noFill/>
+          <a:ln/>
+        </p:spPr>
+        <p:txBody>
+          <a:bodyPr wrap="square" lIns="0" tIns="0" rIns="0" bIns="0" rtlCol="0" anchor="t"/>
+          <a:lstStyle/>
+          <a:p>
+            <a:pPr indent="0" marL="0">
+              <a:buNone/>
+            </a:pPr>
+            <a:r>
+              <a:rPr lang="en-US" sz="1400" dirty="0">
+                <a:solidFill>
+                  <a:schemeClr val="bg1"/>
+                </a:solidFill>
+              </a:rPr>
+              <a:t>En 300 familias E.030 no vistas, Random Forest estimó la deriva con R² 0,99 y detectó 137 de 146 excedencias.</a:t>
+            </a:r>
+            <a:endParaRPr lang="en-US" sz="1400" dirty="0"/>
+          </a:p>
+        </p:txBody>
+      </p:sp>
+      <p:sp>
+        <p:nvSpPr>
+          <p:cNvPr id="9" name="numero"/>
+          <p:cNvSpPr/>
+          <p:nvPr/>
+        </p:nvSpPr>
+        <p:spPr>
+          <a:xfrm>
+            <a:off x="457200" y="2926080"/>
+            <a:ext cx="384048" cy="384048"/>
+          </a:xfrm>
+          <a:prstGeom prst="ellipse">
+            <a:avLst/>
+          </a:prstGeom>
+          <a:solidFill>
+            <a:schemeClr val="accent1"/>
+          </a:solidFill>
+          <a:ln w="12700">
+            <a:solidFill>
+              <a:schemeClr val="accent1"/>
+            </a:solidFill>
+            <a:prstDash val="solid"/>
+          </a:ln>
+        </p:spPr>
+      </p:sp>
+      <p:sp>
+        <p:nvSpPr>
+          <p:cNvPr id="10" name="Text 8"/>
+          <p:cNvSpPr txBox="1"/>
+          <p:nvPr/>
+        </p:nvSpPr>
+        <p:spPr>
+          <a:xfrm>
+            <a:off x="457200" y="2926080"/>
+            <a:ext cx="384048" cy="384048"/>
+          </a:xfrm>
+          <a:prstGeom prst="rect">
+            <a:avLst/>
+          </a:prstGeom>
+          <a:noFill/>
+          <a:ln/>
+        </p:spPr>
+        <p:txBody>
+          <a:bodyPr wrap="square" lIns="0" tIns="0" rIns="0" bIns="0" rtlCol="0" anchor="ctr"/>
+          <a:lstStyle/>
+          <a:p>
+            <a:pPr algn="ctr" indent="0" marL="0">
+              <a:buNone/>
+            </a:pPr>
+            <a:r>
+              <a:rPr lang="en-US" sz="1400" b="1" dirty="0">
+                <a:solidFill>
+                  <a:schemeClr val="bg1"/>
+                </a:solidFill>
+              </a:rPr>
+              <a:t>3</a:t>
+            </a:r>
+            <a:endParaRPr lang="en-US" sz="1400" dirty="0"/>
+          </a:p>
+        </p:txBody>
+      </p:sp>
+      <p:sp>
+        <p:nvSpPr>
+          <p:cNvPr id="11" name="Text 9"/>
+          <p:cNvSpPr txBox="1"/>
+          <p:nvPr/>
+        </p:nvSpPr>
+        <p:spPr>
+          <a:xfrm>
+            <a:off x="1005840" y="2898648"/>
+            <a:ext cx="3931920" cy="777240"/>
+          </a:xfrm>
+          <a:prstGeom prst="rect">
+            <a:avLst/>
+          </a:prstGeom>
+          <a:noFill/>
+          <a:ln/>
+        </p:spPr>
+        <p:txBody>
+          <a:bodyPr wrap="square" lIns="0" tIns="0" rIns="0" bIns="0" rtlCol="0" anchor="t"/>
+          <a:lstStyle/>
+          <a:p>
+            <a:pPr indent="0" marL="0">
+              <a:buNone/>
+            </a:pPr>
+            <a:r>
+              <a:rPr lang="en-US" sz="1400" dirty="0">
+                <a:solidFill>
+                  <a:schemeClr val="bg1"/>
+                </a:solidFill>
+              </a:rPr>
+              <a:t>Con 18 edificios NSR-10 el error baja 39 %, pero solo detecta 3 de 7 casos al límite: los datos mandan más que el algoritmo.</a:t>
+            </a:r>
+            <a:endParaRPr lang="en-US" sz="1400" dirty="0"/>
+          </a:p>
+        </p:txBody>
+      </p:sp>
+      <p:sp>
+        <p:nvSpPr>
+          <p:cNvPr id="12" name="siguientes"/>
+          <p:cNvSpPr/>
+          <p:nvPr/>
+        </p:nvSpPr>
+        <p:spPr>
+          <a:xfrm>
+            <a:off x="5303520" y="1143000"/>
+            <a:ext cx="3383280" cy="3291840"/>
+          </a:xfrm>
+          <a:prstGeom prst="roundRect">
+            <a:avLst>
+              <a:gd name="adj" fmla="val 2222"/>
+            </a:avLst>
+          </a:prstGeom>
+          <a:solidFill>
+            <a:srgbClr val="3A4A57"/>
+          </a:solidFill>
+          <a:ln w="12700">
+            <a:solidFill>
+              <a:srgbClr val="3A4A57"/>
+            </a:solidFill>
+            <a:prstDash val="solid"/>
+          </a:ln>
+        </p:spPr>
+      </p:sp>
+      <p:sp>
+        <p:nvSpPr>
+          <p:cNvPr id="13" name="Text 11"/>
+          <p:cNvSpPr txBox="1"/>
+          <p:nvPr/>
+        </p:nvSpPr>
+        <p:spPr>
+          <a:xfrm>
+            <a:off x="5532120" y="1280160"/>
+            <a:ext cx="3017520" cy="365760"/>
+          </a:xfrm>
+          <a:prstGeom prst="rect">
+            <a:avLst/>
+          </a:prstGeom>
+          <a:noFill/>
+          <a:ln/>
+        </p:spPr>
+        <p:txBody>
+          <a:bodyPr wrap="square" lIns="0" tIns="0" rIns="0" bIns="0" rtlCol="0" anchor="t"/>
+          <a:lstStyle/>
+          <a:p>
+            <a:pPr indent="0" marL="0">
+              <a:buNone/>
+            </a:pPr>
+            <a:r>
+              <a:rPr lang="en-US" sz="1700" b="1" dirty="0">
+                <a:solidFill>
+                  <a:schemeClr val="accent1"/>
+                </a:solidFill>
+              </a:rPr>
+              <a:t>Siguientes pasos</a:t>
+            </a:r>
+            <a:endParaRPr lang="en-US" sz="1700" dirty="0"/>
+          </a:p>
+        </p:txBody>
+      </p:sp>
+      <p:sp>
+        <p:nvSpPr>
+          <p:cNvPr id="14" name="Text 12"/>
+          <p:cNvSpPr txBox="1"/>
+          <p:nvPr/>
+        </p:nvSpPr>
+        <p:spPr>
+          <a:xfrm>
+            <a:off x="5532120" y="1737360"/>
+            <a:ext cx="3017520" cy="2560320"/>
+          </a:xfrm>
+          <a:prstGeom prst="rect">
+            <a:avLst/>
+          </a:prstGeom>
+          <a:noFill/>
+          <a:ln/>
+        </p:spPr>
+        <p:txBody>
+          <a:bodyPr wrap="square" lIns="0" tIns="0" rIns="0" bIns="0" rtlCol="0" anchor="t"/>
+          <a:lstStyle/>
+          <a:p>
+            <a:pPr marL="342900" indent="-342900">
+              <a:spcAft>
+                <a:spcPts val="600"/>
+              </a:spcAft>
+              <a:buSzPct val="100000"/>
+              <a:buChar char="•"/>
+            </a:pPr>
+            <a:r>
+              <a:rPr lang="en-US" sz="1400" dirty="0">
+                <a:solidFill>
+                  <a:schemeClr val="bg1"/>
+                </a:solidFill>
+              </a:rPr>
+              <a:t>Ampliar la base NSR-10 con casos verificados</a:t>
+            </a:r>
+            <a:endParaRPr lang="en-US" sz="1400" dirty="0"/>
+          </a:p>
+          <a:p>
+            <a:pPr marL="342900" indent="-342900">
+              <a:spcAft>
+                <a:spcPts val="600"/>
+              </a:spcAft>
+              <a:buSzPct val="100000"/>
+              <a:buChar char="•"/>
+            </a:pPr>
+            <a:r>
+              <a:rPr lang="en-US" sz="1400" dirty="0">
+                <a:solidFill>
+                  <a:schemeClr val="bg1"/>
+                </a:solidFill>
+              </a:rPr>
+              <a:t>Conectar módulo y predictor al bot de Telegram</a:t>
+            </a:r>
+            <a:endParaRPr lang="en-US" sz="1400" dirty="0"/>
+          </a:p>
+          <a:p>
+            <a:pPr marL="342900" indent="-342900">
+              <a:spcAft>
+                <a:spcPts val="600"/>
+              </a:spcAft>
+              <a:buSzPct val="100000"/>
+              <a:buChar char="•"/>
+            </a:pPr>
+            <a:r>
+              <a:rPr lang="en-US" sz="1400" dirty="0">
+                <a:solidFill>
+                  <a:schemeClr val="bg1"/>
+                </a:solidFill>
+              </a:rPr>
+              <a:t>Cronometrar el flujo completo para medir el ahorro</a:t>
+            </a:r>
+            <a:endParaRPr lang="en-US" sz="1400" dirty="0"/>
+          </a:p>
+        </p:txBody>
+      </p:sp>
+      <p:sp>
+        <p:nvSpPr>
+          <p:cNvPr id="25" name="Slide Number Placeholder 0"/>
+          <p:cNvSpPr>
+            <a:spLocks noGrp="1"/>
+          </p:cNvSpPr>
+          <p:nvPr>
+            <p:ph type="sldNum" sz="quarter" idx="4294967295"/>
+          </p:nvPr>
+        </p:nvSpPr>
+        <p:spPr>
+          <a:xfrm>
+            <a:off x="8229600" y="4773168"/>
+            <a:ext cx="457200" cy="274320"/>
+          </a:xfrm>
+          <a:prstGeom prst="rect">
+            <a:avLst/>
+          </a:prstGeom>
+          <a:extLst>
+            <a:ext uri="{C572A759-6A51-4108-AA02-DFA0A04FC94B}">
+              <ma14:wrappingTextBoxFlag xmlns:ma14="http://schemas.microsoft.com/office/mac/drawingml/2011/main" val="0"/>
+            </a:ext>
+          </a:extLst>
+        </p:spPr>
+        <p:txBody>
+          <a:bodyPr/>
+          <a:lstStyle>
+            <a:lvl1pPr>
+              <a:defRPr sz="900">
+                <a:solidFill>
+                  <a:schemeClr val="accent6"/>
+                </a:solidFill>
+              </a:defRPr>
+            </a:lvl1pPr>
+          </a:lstStyle>
+          <a:p>
+            <a:pPr algn="r"/>
+            <a:fld id="{F7021451-1387-4CA6-816F-3879F97B5CBC}" type="slidenum">
+              <a:rPr b="0" lang="en-US"/>
+              <a:t>14</a:t>
+            </a:fld>
+            <a:endParaRPr lang="en-US"/>
+          </a:p>
+        </p:txBody>
+      </p:sp>
+    </p:spTree>
+  </p:cSld>
+  <p:clrMapOvr>
+    <a:masterClrMapping/>
+  </p:clrMapOvr>
+</p:sld>
+</file>
+
+<file path=ppt/slides/slide15.xml><?xml version="1.0" encoding="utf-8"?>
+<p:sld xmlns:a="http://schemas.openxmlformats.org/drawingml/2006/main" xmlns:r="http://schemas.openxmlformats.org/officeDocument/2006/relationships" xmlns:p="http://schemas.openxmlformats.org/presentationml/2006/main">
+  <p:cSld name="Slide 15">
+    <p:spTree>
+      <p:nvGrpSpPr>
+        <p:cNvPr id="1" name=""/>
+        <p:cNvGrpSpPr/>
+        <p:nvPr/>
+      </p:nvGrpSpPr>
+      <p:grpSpPr>
+        <a:xfrm>
+          <a:off x="0" y="0"/>
+          <a:ext cx="0" cy="0"/>
+          <a:chOff x="0" y="0"/>
+          <a:chExt cx="0" cy="0"/>
+        </a:xfrm>
+      </p:grpSpPr>
+      <p:sp>
+        <p:nvSpPr>
+          <p:cNvPr id="2" name="Text 0"/>
+          <p:cNvSpPr/>
+          <p:nvPr>
+            <p:ph idx="100" type="title" hasCustomPrompt="1"/>
+          </p:nvPr>
+        </p:nvSpPr>
+        <p:spPr>
+          <a:xfrm>
+            <a:off x="457200" y="274320"/>
+            <a:ext cx="8229600" cy="685800"/>
+          </a:xfrm>
+          <a:prstGeom prst="rect">
+            <a:avLst/>
+          </a:prstGeom>
+          <a:noFill/>
+          <a:ln/>
+        </p:spPr>
+        <p:txBody>
+          <a:bodyPr wrap="square" lIns="0" tIns="0" rIns="0" bIns="0" rtlCol="0" anchor="ctr"/>
+          <a:lstStyle/>
+          <a:p>
+            <a:pPr algn="l" indent="0" marL="0">
+              <a:buNone/>
+            </a:pPr>
+            <a:r>
+              <a:rPr lang="en-US" sz="2800" b="1" dirty="0">
+                <a:solidFill>
                   <a:schemeClr val="tx1"/>
                 </a:solidFill>
                 <a:latin typeface="Cambria" pitchFamily="34" charset="0"/>
@@ -5597,7 +6153,7 @@
                   <a:schemeClr val="tx2"/>
                 </a:solidFill>
               </a:rPr>
-              <a:t>Datos, Random Forest y bot n8n</a:t>
+              <a:t>Datos, modelos E.030 y bot n8n</a:t>
             </a:r>
             <a:endParaRPr lang="en-US" sz="1100" dirty="0"/>
           </a:p>
@@ -5898,7 +6454,7 @@
             <a:pPr algn="r"/>
             <a:fld id="{F7021451-1387-4CA6-816F-3879F97B5CBC}" type="slidenum">
               <a:rPr b="0" lang="en-US"/>
-              <a:t>14</a:t>
+              <a:t>15</a:t>
             </a:fld>
             <a:endParaRPr lang="en-US"/>
           </a:p>
@@ -6120,7 +6676,7 @@
                 <a:ea typeface="Cambria" pitchFamily="34" charset="-122"/>
                 <a:cs typeface="Cambria" pitchFamily="34" charset="-120"/>
               </a:rPr>
-              <a:t>130</a:t>
+              <a:t>1 500</a:t>
             </a:r>
             <a:endParaRPr lang="en-US" sz="3600" dirty="0"/>
           </a:p>
@@ -6156,7 +6712,7 @@
                   <a:schemeClr val="tx2"/>
                 </a:solidFill>
               </a:rPr>
-              <a:t>modelos E.030 generados en 49 familias</a:t>
+              <a:t>estructuras E.030 generadas y analizadas en OpenSees</a:t>
             </a:r>
             <a:endParaRPr lang="en-US" sz="1300" dirty="0"/>
           </a:p>
@@ -6222,7 +6778,7 @@
                 <a:ea typeface="Cambria" pitchFamily="34" charset="-122"/>
                 <a:cs typeface="Cambria" pitchFamily="34" charset="-120"/>
               </a:rPr>
-              <a:t>33 %</a:t>
+              <a:t>45 %</a:t>
             </a:r>
             <a:endParaRPr lang="en-US" sz="3600" dirty="0"/>
           </a:p>
@@ -6258,7 +6814,7 @@
                   <a:schemeClr val="tx2"/>
                 </a:solidFill>
               </a:rPr>
-              <a:t>superan el límite de deriva (43 de 130)</a:t>
+              <a:t>superan el límite de deriva (668 de 1 500)</a:t>
             </a:r>
             <a:endParaRPr lang="en-US" sz="1300" dirty="0"/>
           </a:p>
@@ -6981,7 +7537,7 @@
                   <a:schemeClr val="tx2"/>
                 </a:solidFill>
               </a:rPr>
-              <a:t>Random Forest dejando plantas completas fuera</a:t>
+              <a:t>Random Forest en familias y plantas no vistas</a:t>
             </a:r>
             <a:endParaRPr lang="en-US" sz="1400" dirty="0"/>
           </a:p>
@@ -7240,7 +7796,7 @@
                   <a:schemeClr val="tx2"/>
                 </a:solidFill>
               </a:rPr>
-              <a:t>Random Forest con validación por planta; comparado con regresión lineal y referencias</a:t>
+              <a:t>Random Forest en familias no vistas; Gradient Boosting y referencias como comparación</a:t>
             </a:r>
             <a:endParaRPr lang="en-US" sz="1300" dirty="0"/>
           </a:p>
@@ -7684,7 +8240,7 @@
                   <a:schemeClr val="tx2"/>
                 </a:solidFill>
               </a:rPr>
-              <a:t>Base E.030 (130 modelos) y base NSR-10 (18 + 1 casos) con trazabilidad del origen</a:t>
+              <a:t>Base E.030 (1 500 estructuras) y base NSR-10 (18 + 1 casos) con trazabilidad del origen</a:t>
             </a:r>
             <a:endParaRPr lang="en-US" sz="1300" dirty="0"/>
           </a:p>
@@ -7803,7 +8359,7 @@
       </p:sp>
       <p:pic>
         <p:nvPicPr>
-          <p:cNvPr id="3" name="flujo" descr="figuras/fig_flujo_integrado.png">    </p:cNvPr>
+          <p:cNvPr id="3" name="flujo" descr="C:\Users\nicoi\Documents\AECODE Nexo Sismico\07 Outputs\Prototipo NSR-10\figuras\fig_flujo_integrado.png">    </p:cNvPr>
           <p:cNvPicPr>
             <a:picLocks noChangeAspect="1"/>
           </p:cNvPicPr>
@@ -11284,7 +11840,7 @@
       </p:graphicFrame>
       <p:pic>
         <p:nvPicPr>
-          <p:cNvPr id="4" name="derivas" descr="figuras/fig_derivas_caso_curso.png">    </p:cNvPr>
+          <p:cNvPr id="4" name="derivas" descr="C:\Users\nicoi\Documents\AECODE Nexo Sismico\07 Outputs\Prototipo NSR-10\figuras\fig_derivas_caso_curso.png">    </p:cNvPr>
           <p:cNvPicPr>
             <a:picLocks noChangeAspect="1"/>
           </p:cNvPicPr>
@@ -11446,292 +12002,15 @@
                 <a:ea typeface="Cambria" pitchFamily="34" charset="-122"/>
                 <a:cs typeface="Cambria" pitchFamily="34" charset="-120"/>
               </a:rPr>
-              <a:t>Base NSR-10: 18 edificios teóricos + 1 verificado</a:t>
+              <a:t>E.030: Random Forest acierta la deriva con R² 0,99</a:t>
             </a:r>
             <a:endParaRPr lang="en-US" sz="2800" dirty="0"/>
           </a:p>
         </p:txBody>
-      </p:sp>
-      <p:sp>
-        <p:nvSpPr>
-          <p:cNvPr id="3" name="Text 1"/>
-          <p:cNvSpPr txBox="1"/>
-          <p:nvPr/>
-        </p:nvSpPr>
-        <p:spPr>
-          <a:xfrm>
-            <a:off x="457200" y="1188720"/>
-            <a:ext cx="2560320" cy="777240"/>
-          </a:xfrm>
-          <a:prstGeom prst="rect">
-            <a:avLst/>
-          </a:prstGeom>
-          <a:noFill/>
-          <a:ln/>
-        </p:spPr>
-        <p:txBody>
-          <a:bodyPr wrap="square" lIns="0" tIns="0" rIns="0" bIns="0" rtlCol="0" anchor="t"/>
-          <a:lstStyle/>
-          <a:p>
-            <a:pPr indent="0" marL="0">
-              <a:buNone/>
-            </a:pPr>
-            <a:r>
-              <a:rPr lang="en-US" sz="4800" b="1" dirty="0">
-                <a:solidFill>
-                  <a:schemeClr val="accent1"/>
-                </a:solidFill>
-                <a:latin typeface="Cambria" pitchFamily="34" charset="0"/>
-                <a:ea typeface="Cambria" pitchFamily="34" charset="-122"/>
-                <a:cs typeface="Cambria" pitchFamily="34" charset="-120"/>
-              </a:rPr>
-              <a:t>18</a:t>
-            </a:r>
-            <a:endParaRPr lang="en-US" sz="4800" dirty="0"/>
-          </a:p>
-        </p:txBody>
-      </p:sp>
-      <p:sp>
-        <p:nvSpPr>
-          <p:cNvPr id="4" name="Text 2"/>
-          <p:cNvSpPr txBox="1"/>
-          <p:nvPr/>
-        </p:nvSpPr>
-        <p:spPr>
-          <a:xfrm>
-            <a:off x="457200" y="1965960"/>
-            <a:ext cx="2560320" cy="548640"/>
-          </a:xfrm>
-          <a:prstGeom prst="rect">
-            <a:avLst/>
-          </a:prstGeom>
-          <a:noFill/>
-          <a:ln/>
-        </p:spPr>
-        <p:txBody>
-          <a:bodyPr wrap="square" lIns="0" tIns="0" rIns="0" bIns="0" rtlCol="0" anchor="t"/>
-          <a:lstStyle/>
-          <a:p>
-            <a:pPr indent="0" marL="0">
-              <a:buNone/>
-            </a:pPr>
-            <a:r>
-              <a:rPr lang="en-US" sz="1400" dirty="0">
-                <a:solidFill>
-                  <a:schemeClr val="tx2"/>
-                </a:solidFill>
-              </a:rPr>
-              <a:t>edificios del Prof. T. F. Rojas Vallejo (OpenSees)</a:t>
-            </a:r>
-            <a:endParaRPr lang="en-US" sz="1400" dirty="0"/>
-          </a:p>
-        </p:txBody>
-      </p:sp>
-      <p:sp>
-        <p:nvSpPr>
-          <p:cNvPr id="5" name="Text 3"/>
-          <p:cNvSpPr txBox="1"/>
-          <p:nvPr/>
-        </p:nvSpPr>
-        <p:spPr>
-          <a:xfrm>
-            <a:off x="3291840" y="1188720"/>
-            <a:ext cx="2560320" cy="777240"/>
-          </a:xfrm>
-          <a:prstGeom prst="rect">
-            <a:avLst/>
-          </a:prstGeom>
-          <a:noFill/>
-          <a:ln/>
-        </p:spPr>
-        <p:txBody>
-          <a:bodyPr wrap="square" lIns="0" tIns="0" rIns="0" bIns="0" rtlCol="0" anchor="t"/>
-          <a:lstStyle/>
-          <a:p>
-            <a:pPr indent="0" marL="0">
-              <a:buNone/>
-            </a:pPr>
-            <a:r>
-              <a:rPr lang="en-US" sz="4800" b="1" dirty="0">
-                <a:solidFill>
-                  <a:schemeClr val="accent1"/>
-                </a:solidFill>
-                <a:latin typeface="Cambria" pitchFamily="34" charset="0"/>
-                <a:ea typeface="Cambria" pitchFamily="34" charset="-122"/>
-                <a:cs typeface="Cambria" pitchFamily="34" charset="-120"/>
-              </a:rPr>
-              <a:t>9</a:t>
-            </a:r>
-            <a:endParaRPr lang="en-US" sz="4800" dirty="0"/>
-          </a:p>
-        </p:txBody>
-      </p:sp>
-      <p:sp>
-        <p:nvSpPr>
-          <p:cNvPr id="6" name="Text 4"/>
-          <p:cNvSpPr txBox="1"/>
-          <p:nvPr/>
-        </p:nvSpPr>
-        <p:spPr>
-          <a:xfrm>
-            <a:off x="3291840" y="1965960"/>
-            <a:ext cx="2560320" cy="548640"/>
-          </a:xfrm>
-          <a:prstGeom prst="rect">
-            <a:avLst/>
-          </a:prstGeom>
-          <a:noFill/>
-          <a:ln/>
-        </p:spPr>
-        <p:txBody>
-          <a:bodyPr wrap="square" lIns="0" tIns="0" rIns="0" bIns="0" rtlCol="0" anchor="t"/>
-          <a:lstStyle/>
-          <a:p>
-            <a:pPr indent="0" marL="0">
-              <a:buNone/>
-            </a:pPr>
-            <a:r>
-              <a:rPr lang="en-US" sz="1400" dirty="0">
-                <a:solidFill>
-                  <a:schemeClr val="tx2"/>
-                </a:solidFill>
-              </a:rPr>
-              <a:t>plantas, 4 a 10 pisos, Bogotá, DES</a:t>
-            </a:r>
-            <a:endParaRPr lang="en-US" sz="1400" dirty="0"/>
-          </a:p>
-        </p:txBody>
-      </p:sp>
-      <p:sp>
-        <p:nvSpPr>
-          <p:cNvPr id="7" name="Text 5"/>
-          <p:cNvSpPr txBox="1"/>
-          <p:nvPr/>
-        </p:nvSpPr>
-        <p:spPr>
-          <a:xfrm>
-            <a:off x="6126480" y="1188720"/>
-            <a:ext cx="2560320" cy="777240"/>
-          </a:xfrm>
-          <a:prstGeom prst="rect">
-            <a:avLst/>
-          </a:prstGeom>
-          <a:noFill/>
-          <a:ln/>
-        </p:spPr>
-        <p:txBody>
-          <a:bodyPr wrap="square" lIns="0" tIns="0" rIns="0" bIns="0" rtlCol="0" anchor="t"/>
-          <a:lstStyle/>
-          <a:p>
-            <a:pPr indent="0" marL="0">
-              <a:buNone/>
-            </a:pPr>
-            <a:r>
-              <a:rPr lang="en-US" sz="4800" b="1" dirty="0">
-                <a:solidFill>
-                  <a:schemeClr val="accent1"/>
-                </a:solidFill>
-                <a:latin typeface="Cambria" pitchFamily="34" charset="0"/>
-                <a:ea typeface="Cambria" pitchFamily="34" charset="-122"/>
-                <a:cs typeface="Cambria" pitchFamily="34" charset="-120"/>
-              </a:rPr>
-              <a:t>1</a:t>
-            </a:r>
-            <a:endParaRPr lang="en-US" sz="4800" dirty="0"/>
-          </a:p>
-        </p:txBody>
-      </p:sp>
-      <p:sp>
-        <p:nvSpPr>
-          <p:cNvPr id="8" name="Text 6"/>
-          <p:cNvSpPr txBox="1"/>
-          <p:nvPr/>
-        </p:nvSpPr>
-        <p:spPr>
-          <a:xfrm>
-            <a:off x="6126480" y="1965960"/>
-            <a:ext cx="2560320" cy="548640"/>
-          </a:xfrm>
-          <a:prstGeom prst="rect">
-            <a:avLst/>
-          </a:prstGeom>
-          <a:noFill/>
-          <a:ln/>
-        </p:spPr>
-        <p:txBody>
-          <a:bodyPr wrap="square" lIns="0" tIns="0" rIns="0" bIns="0" rtlCol="0" anchor="t"/>
-          <a:lstStyle/>
-          <a:p>
-            <a:pPr indent="0" marL="0">
-              <a:buNone/>
-            </a:pPr>
-            <a:r>
-              <a:rPr lang="en-US" sz="1400" dirty="0">
-                <a:solidFill>
-                  <a:schemeClr val="tx2"/>
-                </a:solidFill>
-              </a:rPr>
-              <a:t>caso del curso verificado con SAP2000</a:t>
-            </a:r>
-            <a:endParaRPr lang="en-US" sz="1400" dirty="0"/>
-          </a:p>
-        </p:txBody>
-      </p:sp>
-      <p:sp>
-        <p:nvSpPr>
-          <p:cNvPr id="9" name="nota_profesor"/>
-          <p:cNvSpPr/>
-          <p:nvPr/>
-        </p:nvSpPr>
-        <p:spPr>
-          <a:xfrm>
-            <a:off x="457200" y="2788920"/>
-            <a:ext cx="8229600" cy="1691640"/>
-          </a:xfrm>
-          <a:prstGeom prst="roundRect">
-            <a:avLst>
-              <a:gd name="adj" fmla="val 4324"/>
-            </a:avLst>
-          </a:prstGeom>
-          <a:solidFill>
-            <a:srgbClr val="EDF0F3"/>
-          </a:solidFill>
-          <a:ln w="12700">
-            <a:solidFill>
-              <a:srgbClr val="EDF0F3"/>
-            </a:solidFill>
-            <a:prstDash val="solid"/>
-          </a:ln>
-        </p:spPr>
-      </p:sp>
-      <p:sp>
-        <p:nvSpPr>
-          <p:cNvPr id="10" name="badge"/>
-          <p:cNvSpPr/>
-          <p:nvPr/>
-        </p:nvSpPr>
-        <p:spPr>
-          <a:xfrm>
-            <a:off x="685800" y="3017520"/>
-            <a:ext cx="502920" cy="502920"/>
-          </a:xfrm>
-          <a:prstGeom prst="ellipse">
-            <a:avLst/>
-          </a:prstGeom>
-          <a:solidFill>
-            <a:schemeClr val="accent5"/>
-          </a:solidFill>
-          <a:ln w="12700">
-            <a:solidFill>
-              <a:schemeClr val="accent5"/>
-            </a:solidFill>
-            <a:prstDash val="solid"/>
-          </a:ln>
-        </p:spPr>
       </p:sp>
       <p:pic>
         <p:nvPicPr>
-          <p:cNvPr id="11" name="icono" descr="preencoded.png">    </p:cNvPr>
+          <p:cNvPr id="3" name="e030_calc_pred" descr="C:\Users\nicoi\Documents\AECODE Nexo Sismico\07 Outputs\E030\fig_e030_calculado_vs_predicho.png">    </p:cNvPr>
           <p:cNvPicPr>
             <a:picLocks noChangeAspect="1"/>
           </p:cNvPicPr>
@@ -11745,8 +12024,8 @@
         </p:blipFill>
         <p:spPr>
           <a:xfrm>
-            <a:off x="796442" y="3128162"/>
-            <a:ext cx="281635" cy="281635"/>
+            <a:off x="457200" y="1097280"/>
+            <a:ext cx="5120640" cy="2276856"/>
           </a:xfrm>
           <a:prstGeom prst="rect">
             <a:avLst/>
@@ -11755,14 +12034,14 @@
       </p:pic>
       <p:sp>
         <p:nvSpPr>
-          <p:cNvPr id="12" name="Text 9"/>
+          <p:cNvPr id="4" name="Text 1"/>
           <p:cNvSpPr txBox="1"/>
           <p:nvPr/>
         </p:nvSpPr>
         <p:spPr>
           <a:xfrm>
-            <a:off x="1371600" y="3017520"/>
-            <a:ext cx="7132320" cy="320040"/>
+            <a:off x="457200" y="3520440"/>
+            <a:ext cx="5120640" cy="685800"/>
           </a:xfrm>
           <a:prstGeom prst="rect">
             <a:avLst/>
@@ -11778,27 +12057,54 @@
               <a:buNone/>
             </a:pPr>
             <a:r>
-              <a:rPr lang="en-US" sz="1500" b="1" dirty="0">
-                <a:solidFill>
-                  <a:schemeClr val="tx1"/>
-                </a:solidFill>
-              </a:rPr>
-              <a:t>Nota del profesor</a:t>
-            </a:r>
-            <a:endParaRPr lang="en-US" sz="1500" dirty="0"/>
-          </a:p>
-        </p:txBody>
-      </p:sp>
-      <p:sp>
-        <p:nvSpPr>
-          <p:cNvPr id="13" name="Text 10"/>
+              <a:rPr lang="en-US" sz="1100" i="1" dirty="0">
+                <a:solidFill>
+                  <a:schemeClr val="tx2"/>
+                </a:solidFill>
+              </a:rPr>
+              <a:t>Prueba única en 300 familias nunca vistas (1 200 para entrenar). Gradient Boosting, como comparación: R² 0,995, MAE 0,026 %, 139 de 146 excedencias.</a:t>
+            </a:r>
+            <a:endParaRPr lang="en-US" sz="1100" dirty="0"/>
+          </a:p>
+        </p:txBody>
+      </p:sp>
+      <p:sp>
+        <p:nvSpPr>
+          <p:cNvPr id="5" name="stat"/>
+          <p:cNvSpPr/>
+          <p:nvPr/>
+        </p:nvSpPr>
+        <p:spPr>
+          <a:xfrm>
+            <a:off x="5852160" y="1097280"/>
+            <a:ext cx="2834640" cy="1463040"/>
+          </a:xfrm>
+          <a:prstGeom prst="roundRect">
+            <a:avLst>
+              <a:gd name="adj" fmla="val 5000"/>
+            </a:avLst>
+          </a:prstGeom>
+          <a:solidFill>
+            <a:schemeClr val="bg2"/>
+          </a:solidFill>
+          <a:ln w="12700">
+            <a:solidFill>
+              <a:schemeClr val="bg2"/>
+            </a:solidFill>
+            <a:prstDash val="solid"/>
+          </a:ln>
+        </p:spPr>
+      </p:sp>
+      <p:sp>
+        <p:nvSpPr>
+          <p:cNvPr id="6" name="Text 3"/>
           <p:cNvSpPr txBox="1"/>
           <p:nvPr/>
         </p:nvSpPr>
         <p:spPr>
           <a:xfrm>
-            <a:off x="1371600" y="3383280"/>
-            <a:ext cx="7132320" cy="1005840"/>
+            <a:off x="6035040" y="1188720"/>
+            <a:ext cx="2560320" cy="731520"/>
           </a:xfrm>
           <a:prstGeom prst="rect">
             <a:avLst/>
@@ -11814,14 +12120,191 @@
               <a:buNone/>
             </a:pPr>
             <a:r>
+              <a:rPr lang="en-US" sz="3600" b="1" dirty="0">
+                <a:solidFill>
+                  <a:schemeClr val="accent1"/>
+                </a:solidFill>
+                <a:latin typeface="Cambria" pitchFamily="34" charset="0"/>
+                <a:ea typeface="Cambria" pitchFamily="34" charset="-122"/>
+                <a:cs typeface="Cambria" pitchFamily="34" charset="-120"/>
+              </a:rPr>
+              <a:t>0,040 %</a:t>
+            </a:r>
+            <a:endParaRPr lang="en-US" sz="3600" dirty="0"/>
+          </a:p>
+        </p:txBody>
+      </p:sp>
+      <p:sp>
+        <p:nvSpPr>
+          <p:cNvPr id="7" name="Text 4"/>
+          <p:cNvSpPr txBox="1"/>
+          <p:nvPr/>
+        </p:nvSpPr>
+        <p:spPr>
+          <a:xfrm>
+            <a:off x="6035040" y="1920240"/>
+            <a:ext cx="2560320" cy="548640"/>
+          </a:xfrm>
+          <a:prstGeom prst="rect">
+            <a:avLst/>
+          </a:prstGeom>
+          <a:noFill/>
+          <a:ln/>
+        </p:spPr>
+        <p:txBody>
+          <a:bodyPr wrap="square" lIns="0" tIns="0" rIns="0" bIns="0" rtlCol="0" anchor="t"/>
+          <a:lstStyle/>
+          <a:p>
+            <a:pPr indent="0" marL="0">
+              <a:buNone/>
+            </a:pPr>
+            <a:r>
               <a:rPr lang="en-US" sz="1300" dirty="0">
                 <a:solidFill>
                   <a:schemeClr val="tx2"/>
                 </a:solidFill>
               </a:rPr>
-              <a:t>Varios resultados son teóricos: algunas plantas y luces no se resolverían con pórticos resistentes a momento en la práctica. Las plantas ausentes fallaron en el dimensionamiento del algoritmo de OpenSees. Por eso estos datos sirven para entrenar y comparar, no como diseños.</a:t>
+              <a:t>error medio de deriva (X e Y), en % de la altura de piso</a:t>
             </a:r>
             <a:endParaRPr lang="en-US" sz="1300" dirty="0"/>
+          </a:p>
+        </p:txBody>
+      </p:sp>
+      <p:sp>
+        <p:nvSpPr>
+          <p:cNvPr id="8" name="stat"/>
+          <p:cNvSpPr/>
+          <p:nvPr/>
+        </p:nvSpPr>
+        <p:spPr>
+          <a:xfrm>
+            <a:off x="5852160" y="2743200"/>
+            <a:ext cx="2834640" cy="1463040"/>
+          </a:xfrm>
+          <a:prstGeom prst="roundRect">
+            <a:avLst>
+              <a:gd name="adj" fmla="val 5000"/>
+            </a:avLst>
+          </a:prstGeom>
+          <a:solidFill>
+            <a:schemeClr val="bg2"/>
+          </a:solidFill>
+          <a:ln w="12700">
+            <a:solidFill>
+              <a:schemeClr val="bg2"/>
+            </a:solidFill>
+            <a:prstDash val="solid"/>
+          </a:ln>
+        </p:spPr>
+      </p:sp>
+      <p:sp>
+        <p:nvSpPr>
+          <p:cNvPr id="9" name="Text 6"/>
+          <p:cNvSpPr txBox="1"/>
+          <p:nvPr/>
+        </p:nvSpPr>
+        <p:spPr>
+          <a:xfrm>
+            <a:off x="6035040" y="2834640"/>
+            <a:ext cx="2560320" cy="731520"/>
+          </a:xfrm>
+          <a:prstGeom prst="rect">
+            <a:avLst/>
+          </a:prstGeom>
+          <a:noFill/>
+          <a:ln/>
+        </p:spPr>
+        <p:txBody>
+          <a:bodyPr wrap="square" lIns="0" tIns="0" rIns="0" bIns="0" rtlCol="0" anchor="t"/>
+          <a:lstStyle/>
+          <a:p>
+            <a:pPr indent="0" marL="0">
+              <a:buNone/>
+            </a:pPr>
+            <a:r>
+              <a:rPr lang="en-US" sz="3600" b="1" dirty="0">
+                <a:solidFill>
+                  <a:schemeClr val="accent3"/>
+                </a:solidFill>
+                <a:latin typeface="Cambria" pitchFamily="34" charset="0"/>
+                <a:ea typeface="Cambria" pitchFamily="34" charset="-122"/>
+                <a:cs typeface="Cambria" pitchFamily="34" charset="-120"/>
+              </a:rPr>
+              <a:t>137 de 146</a:t>
+            </a:r>
+            <a:endParaRPr lang="en-US" sz="3600" dirty="0"/>
+          </a:p>
+        </p:txBody>
+      </p:sp>
+      <p:sp>
+        <p:nvSpPr>
+          <p:cNvPr id="10" name="Text 7"/>
+          <p:cNvSpPr txBox="1"/>
+          <p:nvPr/>
+        </p:nvSpPr>
+        <p:spPr>
+          <a:xfrm>
+            <a:off x="6035040" y="3566160"/>
+            <a:ext cx="2560320" cy="548640"/>
+          </a:xfrm>
+          <a:prstGeom prst="rect">
+            <a:avLst/>
+          </a:prstGeom>
+          <a:noFill/>
+          <a:ln/>
+        </p:spPr>
+        <p:txBody>
+          <a:bodyPr wrap="square" lIns="0" tIns="0" rIns="0" bIns="0" rtlCol="0" anchor="t"/>
+          <a:lstStyle/>
+          <a:p>
+            <a:pPr indent="0" marL="0">
+              <a:buNone/>
+            </a:pPr>
+            <a:r>
+              <a:rPr lang="en-US" sz="1300" dirty="0">
+                <a:solidFill>
+                  <a:schemeClr val="tx2"/>
+                </a:solidFill>
+              </a:rPr>
+              <a:t>edificios que exceden 0,7 % detectados; 2 falsas alarmas</a:t>
+            </a:r>
+            <a:endParaRPr lang="en-US" sz="1300" dirty="0"/>
+          </a:p>
+        </p:txBody>
+      </p:sp>
+      <p:sp>
+        <p:nvSpPr>
+          <p:cNvPr id="11" name="Text 8"/>
+          <p:cNvSpPr txBox="1"/>
+          <p:nvPr/>
+        </p:nvSpPr>
+        <p:spPr>
+          <a:xfrm>
+            <a:off x="457200" y="4343400"/>
+            <a:ext cx="8229600" cy="274320"/>
+          </a:xfrm>
+          <a:prstGeom prst="rect">
+            <a:avLst/>
+          </a:prstGeom>
+          <a:noFill/>
+          <a:ln/>
+        </p:spPr>
+        <p:txBody>
+          <a:bodyPr wrap="square" lIns="0" tIns="0" rIns="0" bIns="0" rtlCol="0" anchor="t"/>
+          <a:lstStyle/>
+          <a:p>
+            <a:pPr indent="0" marL="0">
+              <a:buNone/>
+            </a:pPr>
+            <a:r>
+              <a:rPr lang="en-US" sz="1100" i="1" dirty="0">
+                <a:solidFill>
+                  <a:schemeClr val="accent2"/>
+                </a:solidFill>
+              </a:rPr>
+              <a:t>Los no detectados tienen derivas reales de 0,70 % a 0,76 %: justo en el límite.</a:t>
+            </a:r>
+            <a:endParaRPr lang="en-US" sz="1100" dirty="0"/>
           </a:p>
         </p:txBody>
       </p:sp>
@@ -11879,7 +12362,7 @@
 </file>
 
 <file path=ppt/theme/theme1.xml><?xml version="1.0" encoding="utf-8"?>
-<a:theme xmlns:a="http://schemas.openxmlformats.org/drawingml/2006/main" name="Nexo Sismico">
+<a:theme xmlns:a="http://schemas.openxmlformats.org/drawingml/2006/main" name="Office Theme">
   <a:themeElements>
     <a:clrScheme name="Nexo Sismico">
       <a:dk1>

</xml_diff>

<commit_message>
Memoria compartida para el equipo y sus IAs, guía de trabajo conjunto y videos v2
- 10 Memoria IA/: contexto actual, decisiones (ADR) y sesiones, antes solo en un vault personal
- AGENTS.md (+ CLAUDE.md, GEMINI.md, .github/copilot-instructions.md): reglas y contexto que las IAs leen solas
- README como portada y guía: qué es, resultados, cómo trabajar en conjunto y con IA
- 09 Cowork/instalar_sincronizacion.ps1: cada compañero activa la sincronización cada 15 min
- Videos v2 (prototipo 1:58, ejecutivo 4:36 con la diapositiva E.030): notas del orador acortadas
  y videos.py corta al total exacto de los tramos

Co-Authored-By: Claude Opus 5.5 <noreply@anthropic.com>
</commit_message>
<xml_diff>
--- a/04 Entregables/Presentacion/Presentacion_Nexo_Sismico.pptx
+++ b/04 Entregables/Presentacion/Presentacion_Nexo_Sismico.pptx
@@ -121,31 +121,31 @@
   <p:extLst>
     <p:ext uri="{521415D9-36F7-43E2-AB2F-B90AF26B5E84}">
       <p14:sectionLst xmlns:p14="http://schemas.microsoft.com/office/powerpoint/2010/main">
-        <p14:section name="Apertura" id="{139e17a4-174b-be7e-6245-bc236eaa436a}">
+        <p14:section name="Apertura" id="{2ba3b445-cfc1-1daa-08a5-737c6751740d}">
           <p14:sldIdLst>
             <p14:sldId id="256"/>
           </p14:sldIdLst>
         </p14:section>
-        <p14:section name="Problema y pregunta" id="{965b17fe-4a8f-cb17-ac34-ba2439b139f8}">
+        <p14:section name="Problema y pregunta" id="{fdc3bd7e-c9fe-c632-a352-916d3f5b7b8a}">
           <p14:sldIdLst>
             <p14:sldId id="257"/>
             <p14:sldId id="258"/>
           </p14:sldIdLst>
         </p14:section>
-        <p14:section name="Solución" id="{c2a8df56-fefc-9bd5-da54-78b9ec223bec}">
+        <p14:section name="Solución" id="{018fefba-ef31-7d08-6133-f68f9035755f}">
           <p14:sldIdLst>
             <p14:sldId id="259"/>
             <p14:sldId id="260"/>
           </p14:sldIdLst>
         </p14:section>
-        <p14:section name="Prototipo" id="{4d273800-01bd-e3c8-69ba-0010788d9167}">
+        <p14:section name="Prototipo" id="{6f88d279-cfa5-40f4-643d-82ea538afa13}">
           <p14:sldIdLst>
             <p14:sldId id="261"/>
             <p14:sldId id="262"/>
             <p14:sldId id="263"/>
           </p14:sldIdLst>
         </p14:section>
-        <p14:section name="Resultados" id="{37c8bf5d-4991-535d-4089-e3c9028de20c}">
+        <p14:section name="Resultados" id="{07696f50-6680-38a6-7175-a0a37a31d038}">
           <p14:sldIdLst>
             <p14:sldId id="264"/>
             <p14:sldId id="265"/>
@@ -153,7 +153,7 @@
             <p14:sldId id="267"/>
           </p14:sldIdLst>
         </p14:section>
-        <p14:section name="Cierre" id="{d0bac045-934d-263e-7996-20402bdb3b49}">
+        <p14:section name="Cierre" id="{3e3ea4fd-3e79-ea04-86e1-7d8460135ea1}">
           <p14:sldIdLst>
             <p14:sldId id="268"/>
             <p14:sldId id="269"/>
@@ -1013,7 +1013,7 @@
           <a:p>
             <a:r>
               <a:rPr lang="en-US" dirty="0"/>
-              <a:t>Para la ruta NSR-10 armamos una base con 18 edificios que diseñó el profesor Rojas Vallejo con su algoritmo en OpenSees, más el caso del curso. El profesor nos advirtió que varios son teóricos y que las plantas que faltan fallaron en el dimensionamiento. Los usamos para entrenar y comparar, no como diseños.</a:t>
+              <a:t>Para la ruta colombiana usamos 18 edificios que diseñó el profesor Rojas Vallejo con su algoritmo en OpenSees, más el caso del curso. Varios son teóricos, así que sirven para entrenar y comparar, no como diseños.</a:t>
             </a:r>
             <a:endParaRPr lang="en-US" dirty="0"/>
           </a:p>
@@ -1101,7 +1101,7 @@
           <a:p>
             <a:r>
               <a:rPr lang="en-US" dirty="0"/>
-              <a:t>Evaluamos Random Forest dejando cada planta completa por fuera. Con plantas que nunca vio, su error en la deriva fue de 0,086 puntos en X y 0,101 en Y: un 39 % menos que predecir la media y mejor que la regresión lineal. Cada predicción toma unos 32 milisegundos.</a:t>
+              <a:t>Con plantas NSR-10 que nunca vio, el error de deriva de Random Forest fue de 0,086 puntos en X y 0,101 en Y: un 39 % menos que predecir la media.</a:t>
             </a:r>
             <a:endParaRPr lang="en-US" dirty="0"/>
           </a:p>
@@ -1189,7 +1189,7 @@
           <a:p>
             <a:r>
               <a:rPr lang="en-US" dirty="0"/>
-              <a:t>Pero hay que ser honestos: de siete edificios cerca del límite, el modelo detectó tres y subestimó cuatro. No dio falsas alarmas. Con 18 datos sirve para ordenar alternativas; con 1 500, como en la ruta E.030, la precisión sube de forma drástica. La lección es que ampliar la base colombiana con casos verificados es el siguiente paso.</a:t>
+              <a:t>Con 18 edificios, el modelo detectó tres de siete casos cerca del límite y no dio falsas alarmas. Con tan pocos datos solo sirve para ordenar alternativas; por eso el siguiente paso es ampliar la base colombiana con casos verificados.</a:t>
             </a:r>
             <a:endParaRPr lang="en-US" dirty="0"/>
           </a:p>
@@ -1365,7 +1365,7 @@
           <a:p>
             <a:r>
               <a:rPr lang="en-US" dirty="0"/>
-              <a:t>En conclusión: el módulo NSR-10 reproduce el cálculo de referencia y filtra datos malos; con 1 500 edificios Random Forest estima la deriva de familias nuevas con R² de 0,99 y detecta casi todas las excedencias; con 18 edificios colombianos solo sirve para priorizar. Los siguientes pasos son ampliar la base NSR-10 con casos verificados, conectar todo al bot y medir el ahorro de tiempo real.</a:t>
+              <a:t>En conclusión: el módulo NSR-10 reproduce el cálculo de referencia y filtra datos malos; con 1 500 edificios, Random Forest estima la deriva de familias nuevas con R² de 0,99, y con 18 solo sirve para priorizar. Siguientes pasos: ampliar la base NSR-10, conectar el bot y medir el ahorro de tiempo.</a:t>
             </a:r>
             <a:endParaRPr lang="en-US" dirty="0"/>
           </a:p>
@@ -1453,7 +1453,7 @@
           <a:p>
             <a:r>
               <a:rPr lang="en-US" dirty="0"/>
-              <a:t>Somos cinco: Lucero en el planteamiento, Alexis en la generación y OpenSees, Nicolás en el módulo NSR-10, Jean Piere en datos, modelos E.030 y el bot, y Joseph en validación y coordinación. Agradecemos al profesor Thomas Rojas Vallejo por sus datos. Gracias.</a:t>
+              <a:t>Somos Lucero, Alexis, Nicolás, Jean Piere y Joseph. Agradecemos al profesor Thomas Rojas Vallejo por sus datos. Gracias.</a:t>
             </a:r>
             <a:endParaRPr lang="en-US" dirty="0"/>
           </a:p>
@@ -1629,7 +1629,7 @@
           <a:p>
             <a:r>
               <a:rPr lang="en-US" dirty="0"/>
-              <a:t>Nuestra pregunta es: ¿con qué precisión puede Random Forest estimar las derivas de edificios que no vio en el entrenamiento, y qué ventaja ofrece? Para responderla generamos familias paramétricas, automatizamos la verificación NSR-10 y evaluamos el modelo solo con edificios que no vio al entrenar.</a:t>
+              <a:t>Nuestra pregunta: ¿con qué precisión puede Random Forest estimar las derivas de edificios que no vio al entrenar, y qué ventaja ofrece? Para responderla generamos familias paramétricas, automatizamos la verificación NSR-10 y evaluamos solo con edificios nuevos.</a:t>
             </a:r>
             <a:endParaRPr lang="en-US" dirty="0"/>
           </a:p>
@@ -1805,7 +1805,7 @@
           <a:p>
             <a:r>
               <a:rPr lang="en-US" dirty="0"/>
-              <a:t>La arquitectura tiene dos rutas de evidencia que no se mezclan, porque las normas difieren: la ruta E.030 con 1 500 edificios paramétricos en OpenSees y la ruta NSR-10 con el módulo de verificación y los edificios del profesor Rojas Vallejo. Ambas alimentan el mismo método de Random Forest y la interfaz propuesta en Telegram.</a:t>
+              <a:t>La arquitectura tiene dos rutas que no se mezclan porque las normas difieren: la ruta E.030, con 1 500 edificios paramétricos en OpenSees, y la ruta NSR-10, con el módulo de verificación y los edificios del profesor Rojas Vallejo. Ambas alimentan el mismo método de evaluación.</a:t>
             </a:r>
             <a:endParaRPr lang="en-US" dirty="0"/>
           </a:p>
@@ -1893,7 +1893,7 @@
           <a:p>
             <a:r>
               <a:rPr lang="en-US" dirty="0"/>
-              <a:t>El prototipo es el módulo NSR-10 en Python. Recibe un JSON con el sitio, la geometría, los pesos y los resultados de SAP2000. Primero valida; luego calcula espectro, fuerza horizontal equivalente, derivas de doce combinaciones con torsión accidental, estabilidad P-Delta, irregularidad torsional y R. Al final escribe un reporte y una fila para la base de datos. Todo en menos de un milisegundo.</a:t>
+              <a:t>El prototipo es el módulo NSR-10 en Python. Recibe un JSON con el sitio, la geometría, los pesos y los resultados de SAP2000; primero valida y luego calcula espectro, fuerza horizontal equivalente, derivas de doce combinaciones con torsión accidental, estabilidad y R. Todo en menos de un milisegundo.</a:t>
             </a:r>
             <a:endParaRPr lang="en-US" dirty="0"/>
           </a:p>
@@ -1981,7 +1981,7 @@
           <a:p>
             <a:r>
               <a:rPr lang="en-US" dirty="0"/>
-              <a:t>Lo probamos con tres casos. Con datos completos, el edificio del curso en Piedemonte A da un cortante de 23 250 kilonewtons y una deriva máxima de 0,99 %: cumple. Si falta un dato, como Fv, se detiene y dice cuál falta. Si un dato está mal, como una altura escrita en centímetros, lo rechaza y explica el rango válido.</a:t>
+              <a:t>Lo probamos con tres casos. Con datos completos, el edificio del curso da 23 250 kilonewtons de cortante y 0,99 % de deriva: cumple. Si falta un dato, como Fv, se detiene y dice cuál falta. Si un dato está mal, como una altura en centímetros, lo rechaza.</a:t>
             </a:r>
             <a:endParaRPr lang="en-US" dirty="0"/>
           </a:p>
@@ -2157,7 +2157,7 @@
           <a:p>
             <a:r>
               <a:rPr lang="en-US" dirty="0"/>
-              <a:t>Esta es la respuesta principal a la pregunta. En la ruta peruana generamos y analizamos 1 500 edificios en OpenSees. Entrenamos Random Forest con 1 200 y lo probamos una sola vez con 300 familias que nunca vio. Su error medio en la deriva fue de 0,04 puntos porcentuales, con R² de 0,99, y detectó 137 de los 146 edificios que exceden el límite. Los que se le escapan están justo en el límite, entre 0,70 y 0,76 %. Como comparación, Gradient Boosting mejora un poco: R² de 0,995 y 139 detectados. La diferencia entre algoritmos es pequeña; lo que manda son los datos y las variables físicas.</a:t>
+              <a:t>Esta es la respuesta principal. Generamos y analizamos 1 500 edificios en OpenSees, entrenamos Random Forest con 1 200 y lo probamos una sola vez con 300 familias que nunca vio. Su error medio en la deriva fue de 0,04 puntos, con R² de 0,99, y detectó 137 de 146 excedencias; las que se le escapan están justo en el límite. Gradient Boosting, como comparación, mejora poco: lo que manda son los datos.</a:t>
             </a:r>
             <a:endParaRPr lang="en-US" dirty="0"/>
           </a:p>

</xml_diff>

<commit_message>
Nombres oficiales del equipo y entrega completa del Reto 06 (prototipo funcional)
- equipo.json: nombres oficiales, usados por informe, presentación, ficha y demo
- Informe, presentación (portada y equipo), ficha y video ejecutivo regenerados con los nombres
- Ficha técnica de 1 página con las secciones de la orden de trabajo
- demo_en_vivo.py y capturas reales de las 3 pruebas (grabación en vivo de la consola)
- prototipo_docs.py: Esquema_prototipo.png y Definicion_prototipo.pdf (plantilla de medición sin cifras inventadas)
- Checklist de entrega y orden de trabajo en el vault; memoria actualizada

Co-Authored-By: Claude Opus 5.5 <noreply@anthropic.com>
</commit_message>
<xml_diff>
--- a/04 Entregables/Presentacion/Presentacion_Nexo_Sismico.pptx
+++ b/04 Entregables/Presentacion/Presentacion_Nexo_Sismico.pptx
@@ -121,31 +121,31 @@
   <p:extLst>
     <p:ext uri="{521415D9-36F7-43E2-AB2F-B90AF26B5E84}">
       <p14:sectionLst xmlns:p14="http://schemas.microsoft.com/office/powerpoint/2010/main">
-        <p14:section name="Apertura" id="{2ba3b445-cfc1-1daa-08a5-737c6751740d}">
+        <p14:section name="Apertura" id="{dad3f2e7-3ce3-7795-d2ff-d0dc4aa96de6}">
           <p14:sldIdLst>
             <p14:sldId id="256"/>
           </p14:sldIdLst>
         </p14:section>
-        <p14:section name="Problema y pregunta" id="{fdc3bd7e-c9fe-c632-a352-916d3f5b7b8a}">
+        <p14:section name="Problema y pregunta" id="{009930da-392e-7bb7-6854-a3f2272109a2}">
           <p14:sldIdLst>
             <p14:sldId id="257"/>
             <p14:sldId id="258"/>
           </p14:sldIdLst>
         </p14:section>
-        <p14:section name="Solución" id="{018fefba-ef31-7d08-6133-f68f9035755f}">
+        <p14:section name="Solución" id="{9b8327de-8759-4d23-f189-4a7224881997}">
           <p14:sldIdLst>
             <p14:sldId id="259"/>
             <p14:sldId id="260"/>
           </p14:sldIdLst>
         </p14:section>
-        <p14:section name="Prototipo" id="{6f88d279-cfa5-40f4-643d-82ea538afa13}">
+        <p14:section name="Prototipo" id="{edc0dc12-ee4e-40da-5e6d-9e3738979dfc}">
           <p14:sldIdLst>
             <p14:sldId id="261"/>
             <p14:sldId id="262"/>
             <p14:sldId id="263"/>
           </p14:sldIdLst>
         </p14:section>
-        <p14:section name="Resultados" id="{07696f50-6680-38a6-7175-a0a37a31d038}">
+        <p14:section name="Resultados" id="{c00728f1-9a33-5e60-288a-61868ab13759}">
           <p14:sldIdLst>
             <p14:sldId id="264"/>
             <p14:sldId id="265"/>
@@ -153,7 +153,7 @@
             <p14:sldId id="267"/>
           </p14:sldIdLst>
         </p14:section>
-        <p14:section name="Cierre" id="{3e3ea4fd-3e79-ea04-86e1-7d8460135ea1}">
+        <p14:section name="Cierre" id="{1c149de2-a789-135c-f22e-0b76299f8a1f}">
           <p14:sldIdLst>
             <p14:sldId id="268"/>
             <p14:sldId id="269"/>
@@ -1453,7 +1453,7 @@
           <a:p>
             <a:r>
               <a:rPr lang="en-US" dirty="0"/>
-              <a:t>Somos Lucero, Alexis, Nicolás, Jean Piere y Joseph. Agradecemos al profesor Thomas Rojas Vallejo por sus datos. Gracias.</a:t>
+              <a:t>Somos Lucero Vargas, Alexis Huamani, Nicolás Infante, Jean Piere Velásquez y Joseph Ccana. Agradecemos al profesor Thomas Rojas Vallejo por sus datos. Gracias.</a:t>
             </a:r>
             <a:endParaRPr lang="en-US" dirty="0"/>
           </a:p>
@@ -3081,8 +3081,8 @@
         </p:nvSpPr>
         <p:spPr>
           <a:xfrm>
-            <a:off x="548640" y="3977640"/>
-            <a:ext cx="7315200" cy="274320"/>
+            <a:off x="548640" y="3703320"/>
+            <a:ext cx="7132320" cy="548640"/>
           </a:xfrm>
           <a:prstGeom prst="rect">
             <a:avLst/>
@@ -3098,14 +3098,14 @@
               <a:buNone/>
             </a:pPr>
             <a:r>
-              <a:rPr lang="en-US" sz="1400" dirty="0">
+              <a:rPr lang="en-US" sz="1200" dirty="0">
                 <a:solidFill>
                   <a:schemeClr val="bg1"/>
                 </a:solidFill>
               </a:rPr>
-              <a:t>Lucero · Alexis · Nicolás Infante · Jean Piere · Joseph</a:t>
-            </a:r>
-            <a:endParaRPr lang="en-US" sz="1400" dirty="0"/>
+              <a:t>Lucero Vivivana Vargas Silva · Oswer Alexis Huamani · Nicolás Infante Hernández · Jean Piere Velásquez Quispe · Joseph Leonardo Ccana Ayuque</a:t>
+            </a:r>
+            <a:endParaRPr lang="en-US" sz="1200" dirty="0"/>
           </a:p>
         </p:txBody>
       </p:sp>
@@ -5575,8 +5575,8 @@
         </p:nvSpPr>
         <p:spPr>
           <a:xfrm>
-            <a:off x="457200" y="1188720"/>
-            <a:ext cx="1536192" cy="1737360"/>
+            <a:off x="457200" y="1097280"/>
+            <a:ext cx="1536192" cy="2103120"/>
           </a:xfrm>
           <a:prstGeom prst="roundRect">
             <a:avLst>
@@ -5602,7 +5602,7 @@
         </p:nvSpPr>
         <p:spPr>
           <a:xfrm>
-            <a:off x="950976" y="1325880"/>
+            <a:off x="950976" y="1207008"/>
             <a:ext cx="548640" cy="548640"/>
           </a:xfrm>
           <a:prstGeom prst="ellipse">
@@ -5635,7 +5635,7 @@
         </p:blipFill>
         <p:spPr>
           <a:xfrm>
-            <a:off x="1071677" y="1446581"/>
+            <a:off x="1071677" y="1327709"/>
             <a:ext cx="307238" cy="307238"/>
           </a:xfrm>
           <a:prstGeom prst="rect">
@@ -5651,31 +5651,31 @@
         </p:nvSpPr>
         <p:spPr>
           <a:xfrm>
-            <a:off x="530352" y="1965960"/>
-            <a:ext cx="1389888" cy="320040"/>
-          </a:xfrm>
-          <a:prstGeom prst="rect">
-            <a:avLst/>
-          </a:prstGeom>
-          <a:noFill/>
-          <a:ln/>
-        </p:spPr>
-        <p:txBody>
-          <a:bodyPr wrap="square" lIns="0" tIns="0" rIns="0" bIns="0" rtlCol="0" anchor="t"/>
+            <a:off x="530352" y="1828800"/>
+            <a:ext cx="1389888" cy="640080"/>
+          </a:xfrm>
+          <a:prstGeom prst="rect">
+            <a:avLst/>
+          </a:prstGeom>
+          <a:noFill/>
+          <a:ln/>
+        </p:spPr>
+        <p:txBody>
+          <a:bodyPr wrap="square" lIns="0" tIns="0" rIns="0" bIns="0" rtlCol="0" anchor="ctr"/>
           <a:lstStyle/>
           <a:p>
             <a:pPr algn="ctr" indent="0" marL="0">
               <a:buNone/>
             </a:pPr>
             <a:r>
-              <a:rPr lang="en-US" sz="1400" b="1" dirty="0">
+              <a:rPr lang="en-US" sz="1200" b="1" dirty="0">
                 <a:solidFill>
                   <a:schemeClr val="tx1"/>
                 </a:solidFill>
               </a:rPr>
-              <a:t>Lucero</a:t>
-            </a:r>
-            <a:endParaRPr lang="en-US" sz="1400" dirty="0"/>
+              <a:t>Lucero Vivivana Vargas Silva</a:t>
+            </a:r>
+            <a:endParaRPr lang="en-US" sz="1200" dirty="0"/>
           </a:p>
         </p:txBody>
       </p:sp>
@@ -5687,7 +5687,7 @@
         </p:nvSpPr>
         <p:spPr>
           <a:xfrm>
-            <a:off x="530352" y="2286000"/>
+            <a:off x="530352" y="2514600"/>
             <a:ext cx="1389888" cy="594360"/>
           </a:xfrm>
           <a:prstGeom prst="rect">
@@ -5704,14 +5704,14 @@
               <a:buNone/>
             </a:pPr>
             <a:r>
-              <a:rPr lang="en-US" sz="1100" dirty="0">
+              <a:rPr lang="en-US" sz="1050" dirty="0">
                 <a:solidFill>
                   <a:schemeClr val="tx2"/>
                 </a:solidFill>
               </a:rPr>
               <a:t>Planteamiento académico</a:t>
             </a:r>
-            <a:endParaRPr lang="en-US" sz="1100" dirty="0"/>
+            <a:endParaRPr lang="en-US" sz="1050" dirty="0"/>
           </a:p>
         </p:txBody>
       </p:sp>
@@ -5723,8 +5723,8 @@
         </p:nvSpPr>
         <p:spPr>
           <a:xfrm>
-            <a:off x="2139696" y="1188720"/>
-            <a:ext cx="1536192" cy="1737360"/>
+            <a:off x="2139696" y="1097280"/>
+            <a:ext cx="1536192" cy="2103120"/>
           </a:xfrm>
           <a:prstGeom prst="roundRect">
             <a:avLst>
@@ -5750,7 +5750,7 @@
         </p:nvSpPr>
         <p:spPr>
           <a:xfrm>
-            <a:off x="2633472" y="1325880"/>
+            <a:off x="2633472" y="1207008"/>
             <a:ext cx="548640" cy="548640"/>
           </a:xfrm>
           <a:prstGeom prst="ellipse">
@@ -5783,7 +5783,7 @@
         </p:blipFill>
         <p:spPr>
           <a:xfrm>
-            <a:off x="2754173" y="1446581"/>
+            <a:off x="2754173" y="1327709"/>
             <a:ext cx="307238" cy="307238"/>
           </a:xfrm>
           <a:prstGeom prst="rect">
@@ -5799,31 +5799,31 @@
         </p:nvSpPr>
         <p:spPr>
           <a:xfrm>
-            <a:off x="2212848" y="1965960"/>
-            <a:ext cx="1389888" cy="320040"/>
-          </a:xfrm>
-          <a:prstGeom prst="rect">
-            <a:avLst/>
-          </a:prstGeom>
-          <a:noFill/>
-          <a:ln/>
-        </p:spPr>
-        <p:txBody>
-          <a:bodyPr wrap="square" lIns="0" tIns="0" rIns="0" bIns="0" rtlCol="0" anchor="t"/>
+            <a:off x="2212848" y="1828800"/>
+            <a:ext cx="1389888" cy="640080"/>
+          </a:xfrm>
+          <a:prstGeom prst="rect">
+            <a:avLst/>
+          </a:prstGeom>
+          <a:noFill/>
+          <a:ln/>
+        </p:spPr>
+        <p:txBody>
+          <a:bodyPr wrap="square" lIns="0" tIns="0" rIns="0" bIns="0" rtlCol="0" anchor="ctr"/>
           <a:lstStyle/>
           <a:p>
             <a:pPr algn="ctr" indent="0" marL="0">
               <a:buNone/>
             </a:pPr>
             <a:r>
-              <a:rPr lang="en-US" sz="1400" b="1" dirty="0">
+              <a:rPr lang="en-US" sz="1200" b="1" dirty="0">
                 <a:solidFill>
                   <a:schemeClr val="tx1"/>
                 </a:solidFill>
               </a:rPr>
-              <a:t>Alexis</a:t>
-            </a:r>
-            <a:endParaRPr lang="en-US" sz="1400" dirty="0"/>
+              <a:t>Oswer Alexis Huamani</a:t>
+            </a:r>
+            <a:endParaRPr lang="en-US" sz="1200" dirty="0"/>
           </a:p>
         </p:txBody>
       </p:sp>
@@ -5835,7 +5835,7 @@
         </p:nvSpPr>
         <p:spPr>
           <a:xfrm>
-            <a:off x="2212848" y="2286000"/>
+            <a:off x="2212848" y="2514600"/>
             <a:ext cx="1389888" cy="594360"/>
           </a:xfrm>
           <a:prstGeom prst="rect">
@@ -5852,14 +5852,14 @@
               <a:buNone/>
             </a:pPr>
             <a:r>
-              <a:rPr lang="en-US" sz="1100" dirty="0">
+              <a:rPr lang="en-US" sz="1050" dirty="0">
                 <a:solidFill>
                   <a:schemeClr val="tx2"/>
                 </a:solidFill>
               </a:rPr>
               <a:t>Generación paramétrica y OpenSees</a:t>
             </a:r>
-            <a:endParaRPr lang="en-US" sz="1100" dirty="0"/>
+            <a:endParaRPr lang="en-US" sz="1050" dirty="0"/>
           </a:p>
         </p:txBody>
       </p:sp>
@@ -5871,8 +5871,8 @@
         </p:nvSpPr>
         <p:spPr>
           <a:xfrm>
-            <a:off x="3822192" y="1188720"/>
-            <a:ext cx="1536192" cy="1737360"/>
+            <a:off x="3822192" y="1097280"/>
+            <a:ext cx="1536192" cy="2103120"/>
           </a:xfrm>
           <a:prstGeom prst="roundRect">
             <a:avLst>
@@ -5898,7 +5898,7 @@
         </p:nvSpPr>
         <p:spPr>
           <a:xfrm>
-            <a:off x="4315968" y="1325880"/>
+            <a:off x="4315968" y="1207008"/>
             <a:ext cx="548640" cy="548640"/>
           </a:xfrm>
           <a:prstGeom prst="ellipse">
@@ -5931,7 +5931,7 @@
         </p:blipFill>
         <p:spPr>
           <a:xfrm>
-            <a:off x="4436669" y="1446581"/>
+            <a:off x="4436669" y="1327709"/>
             <a:ext cx="307238" cy="307238"/>
           </a:xfrm>
           <a:prstGeom prst="rect">
@@ -5947,31 +5947,31 @@
         </p:nvSpPr>
         <p:spPr>
           <a:xfrm>
-            <a:off x="3895344" y="1965960"/>
-            <a:ext cx="1389888" cy="320040"/>
-          </a:xfrm>
-          <a:prstGeom prst="rect">
-            <a:avLst/>
-          </a:prstGeom>
-          <a:noFill/>
-          <a:ln/>
-        </p:spPr>
-        <p:txBody>
-          <a:bodyPr wrap="square" lIns="0" tIns="0" rIns="0" bIns="0" rtlCol="0" anchor="t"/>
+            <a:off x="3895344" y="1828800"/>
+            <a:ext cx="1389888" cy="640080"/>
+          </a:xfrm>
+          <a:prstGeom prst="rect">
+            <a:avLst/>
+          </a:prstGeom>
+          <a:noFill/>
+          <a:ln/>
+        </p:spPr>
+        <p:txBody>
+          <a:bodyPr wrap="square" lIns="0" tIns="0" rIns="0" bIns="0" rtlCol="0" anchor="ctr"/>
           <a:lstStyle/>
           <a:p>
             <a:pPr algn="ctr" indent="0" marL="0">
               <a:buNone/>
             </a:pPr>
             <a:r>
-              <a:rPr lang="en-US" sz="1400" b="1" dirty="0">
+              <a:rPr lang="en-US" sz="1200" b="1" dirty="0">
                 <a:solidFill>
                   <a:schemeClr val="tx1"/>
                 </a:solidFill>
               </a:rPr>
-              <a:t>Nicolás Infante</a:t>
-            </a:r>
-            <a:endParaRPr lang="en-US" sz="1400" dirty="0"/>
+              <a:t>Nicolás Infante Hernández</a:t>
+            </a:r>
+            <a:endParaRPr lang="en-US" sz="1200" dirty="0"/>
           </a:p>
         </p:txBody>
       </p:sp>
@@ -5983,7 +5983,7 @@
         </p:nvSpPr>
         <p:spPr>
           <a:xfrm>
-            <a:off x="3895344" y="2286000"/>
+            <a:off x="3895344" y="2514600"/>
             <a:ext cx="1389888" cy="594360"/>
           </a:xfrm>
           <a:prstGeom prst="rect">
@@ -6000,14 +6000,14 @@
               <a:buNone/>
             </a:pPr>
             <a:r>
-              <a:rPr lang="en-US" sz="1100" dirty="0">
+              <a:rPr lang="en-US" sz="1050" dirty="0">
                 <a:solidFill>
                   <a:schemeClr val="tx2"/>
                 </a:solidFill>
               </a:rPr>
               <a:t>Módulo NSR-10 y SAP2000</a:t>
             </a:r>
-            <a:endParaRPr lang="en-US" sz="1100" dirty="0"/>
+            <a:endParaRPr lang="en-US" sz="1050" dirty="0"/>
           </a:p>
         </p:txBody>
       </p:sp>
@@ -6019,8 +6019,8 @@
         </p:nvSpPr>
         <p:spPr>
           <a:xfrm>
-            <a:off x="5504688" y="1188720"/>
-            <a:ext cx="1536192" cy="1737360"/>
+            <a:off x="5504688" y="1097280"/>
+            <a:ext cx="1536192" cy="2103120"/>
           </a:xfrm>
           <a:prstGeom prst="roundRect">
             <a:avLst>
@@ -6046,7 +6046,7 @@
         </p:nvSpPr>
         <p:spPr>
           <a:xfrm>
-            <a:off x="5998464" y="1325880"/>
+            <a:off x="5998464" y="1207008"/>
             <a:ext cx="548640" cy="548640"/>
           </a:xfrm>
           <a:prstGeom prst="ellipse">
@@ -6079,7 +6079,7 @@
         </p:blipFill>
         <p:spPr>
           <a:xfrm>
-            <a:off x="6119165" y="1446581"/>
+            <a:off x="6119165" y="1327709"/>
             <a:ext cx="307238" cy="307238"/>
           </a:xfrm>
           <a:prstGeom prst="rect">
@@ -6095,31 +6095,31 @@
         </p:nvSpPr>
         <p:spPr>
           <a:xfrm>
-            <a:off x="5577840" y="1965960"/>
-            <a:ext cx="1389888" cy="320040"/>
-          </a:xfrm>
-          <a:prstGeom prst="rect">
-            <a:avLst/>
-          </a:prstGeom>
-          <a:noFill/>
-          <a:ln/>
-        </p:spPr>
-        <p:txBody>
-          <a:bodyPr wrap="square" lIns="0" tIns="0" rIns="0" bIns="0" rtlCol="0" anchor="t"/>
+            <a:off x="5577840" y="1828800"/>
+            <a:ext cx="1389888" cy="640080"/>
+          </a:xfrm>
+          <a:prstGeom prst="rect">
+            <a:avLst/>
+          </a:prstGeom>
+          <a:noFill/>
+          <a:ln/>
+        </p:spPr>
+        <p:txBody>
+          <a:bodyPr wrap="square" lIns="0" tIns="0" rIns="0" bIns="0" rtlCol="0" anchor="ctr"/>
           <a:lstStyle/>
           <a:p>
             <a:pPr algn="ctr" indent="0" marL="0">
               <a:buNone/>
             </a:pPr>
             <a:r>
-              <a:rPr lang="en-US" sz="1400" b="1" dirty="0">
+              <a:rPr lang="en-US" sz="1200" b="1" dirty="0">
                 <a:solidFill>
                   <a:schemeClr val="tx1"/>
                 </a:solidFill>
               </a:rPr>
-              <a:t>Jean Piere</a:t>
-            </a:r>
-            <a:endParaRPr lang="en-US" sz="1400" dirty="0"/>
+              <a:t>Jean Piere Velásquez Quispe</a:t>
+            </a:r>
+            <a:endParaRPr lang="en-US" sz="1200" dirty="0"/>
           </a:p>
         </p:txBody>
       </p:sp>
@@ -6131,7 +6131,7 @@
         </p:nvSpPr>
         <p:spPr>
           <a:xfrm>
-            <a:off x="5577840" y="2286000"/>
+            <a:off x="5577840" y="2514600"/>
             <a:ext cx="1389888" cy="594360"/>
           </a:xfrm>
           <a:prstGeom prst="rect">
@@ -6148,14 +6148,14 @@
               <a:buNone/>
             </a:pPr>
             <a:r>
-              <a:rPr lang="en-US" sz="1100" dirty="0">
+              <a:rPr lang="en-US" sz="1050" dirty="0">
                 <a:solidFill>
                   <a:schemeClr val="tx2"/>
                 </a:solidFill>
               </a:rPr>
               <a:t>Datos, modelos E.030 y bot n8n</a:t>
             </a:r>
-            <a:endParaRPr lang="en-US" sz="1100" dirty="0"/>
+            <a:endParaRPr lang="en-US" sz="1050" dirty="0"/>
           </a:p>
         </p:txBody>
       </p:sp>
@@ -6167,8 +6167,8 @@
         </p:nvSpPr>
         <p:spPr>
           <a:xfrm>
-            <a:off x="7187184" y="1188720"/>
-            <a:ext cx="1536192" cy="1737360"/>
+            <a:off x="7187184" y="1097280"/>
+            <a:ext cx="1536192" cy="2103120"/>
           </a:xfrm>
           <a:prstGeom prst="roundRect">
             <a:avLst>
@@ -6194,7 +6194,7 @@
         </p:nvSpPr>
         <p:spPr>
           <a:xfrm>
-            <a:off x="7680960" y="1325880"/>
+            <a:off x="7680960" y="1207008"/>
             <a:ext cx="548640" cy="548640"/>
           </a:xfrm>
           <a:prstGeom prst="ellipse">
@@ -6227,7 +6227,7 @@
         </p:blipFill>
         <p:spPr>
           <a:xfrm>
-            <a:off x="7801661" y="1446581"/>
+            <a:off x="7801661" y="1327709"/>
             <a:ext cx="307238" cy="307238"/>
           </a:xfrm>
           <a:prstGeom prst="rect">
@@ -6243,31 +6243,31 @@
         </p:nvSpPr>
         <p:spPr>
           <a:xfrm>
-            <a:off x="7260336" y="1965960"/>
-            <a:ext cx="1389888" cy="320040"/>
-          </a:xfrm>
-          <a:prstGeom prst="rect">
-            <a:avLst/>
-          </a:prstGeom>
-          <a:noFill/>
-          <a:ln/>
-        </p:spPr>
-        <p:txBody>
-          <a:bodyPr wrap="square" lIns="0" tIns="0" rIns="0" bIns="0" rtlCol="0" anchor="t"/>
+            <a:off x="7260336" y="1828800"/>
+            <a:ext cx="1389888" cy="640080"/>
+          </a:xfrm>
+          <a:prstGeom prst="rect">
+            <a:avLst/>
+          </a:prstGeom>
+          <a:noFill/>
+          <a:ln/>
+        </p:spPr>
+        <p:txBody>
+          <a:bodyPr wrap="square" lIns="0" tIns="0" rIns="0" bIns="0" rtlCol="0" anchor="ctr"/>
           <a:lstStyle/>
           <a:p>
             <a:pPr algn="ctr" indent="0" marL="0">
               <a:buNone/>
             </a:pPr>
             <a:r>
-              <a:rPr lang="en-US" sz="1400" b="1" dirty="0">
+              <a:rPr lang="en-US" sz="1200" b="1" dirty="0">
                 <a:solidFill>
                   <a:schemeClr val="tx1"/>
                 </a:solidFill>
               </a:rPr>
-              <a:t>Joseph</a:t>
-            </a:r>
-            <a:endParaRPr lang="en-US" sz="1400" dirty="0"/>
+              <a:t>Joseph Leonardo Ccana Ayuque</a:t>
+            </a:r>
+            <a:endParaRPr lang="en-US" sz="1200" dirty="0"/>
           </a:p>
         </p:txBody>
       </p:sp>
@@ -6279,7 +6279,7 @@
         </p:nvSpPr>
         <p:spPr>
           <a:xfrm>
-            <a:off x="7260336" y="2286000"/>
+            <a:off x="7260336" y="2514600"/>
             <a:ext cx="1389888" cy="594360"/>
           </a:xfrm>
           <a:prstGeom prst="rect">
@@ -6296,14 +6296,14 @@
               <a:buNone/>
             </a:pPr>
             <a:r>
-              <a:rPr lang="en-US" sz="1100" dirty="0">
+              <a:rPr lang="en-US" sz="1050" dirty="0">
                 <a:solidFill>
                   <a:schemeClr val="tx2"/>
                 </a:solidFill>
               </a:rPr>
               <a:t>Validación y coordinación</a:t>
             </a:r>
-            <a:endParaRPr lang="en-US" sz="1100" dirty="0"/>
+            <a:endParaRPr lang="en-US" sz="1050" dirty="0"/>
           </a:p>
         </p:txBody>
       </p:sp>
@@ -6315,7 +6315,7 @@
         </p:nvSpPr>
         <p:spPr>
           <a:xfrm>
-            <a:off x="457200" y="3200400"/>
+            <a:off x="457200" y="3383280"/>
             <a:ext cx="8229600" cy="320040"/>
           </a:xfrm>
           <a:prstGeom prst="rect">
@@ -6351,8 +6351,8 @@
         </p:nvSpPr>
         <p:spPr>
           <a:xfrm>
-            <a:off x="457200" y="3566160"/>
-            <a:ext cx="8229600" cy="548640"/>
+            <a:off x="457200" y="3703320"/>
+            <a:ext cx="8229600" cy="502920"/>
           </a:xfrm>
           <a:prstGeom prst="rect">
             <a:avLst/>
@@ -6368,14 +6368,14 @@
               <a:buNone/>
             </a:pPr>
             <a:r>
-              <a:rPr lang="en-US" sz="1400" dirty="0">
+              <a:rPr lang="en-US" sz="1300" dirty="0">
                 <a:solidFill>
                   <a:schemeClr val="tx2"/>
                 </a:solidFill>
               </a:rPr>
               <a:t>Python · OpenSeesPy · SAP2000 · scikit-learn · n8n · Telegram · asistentes de IA generativa para programación · Obsidian · GitHub · Discord · Miro</a:t>
             </a:r>
-            <a:endParaRPr lang="en-US" sz="1400" dirty="0"/>
+            <a:endParaRPr lang="en-US" sz="1300" dirty="0"/>
           </a:p>
         </p:txBody>
       </p:sp>
@@ -6387,7 +6387,7 @@
         </p:nvSpPr>
         <p:spPr>
           <a:xfrm>
-            <a:off x="457200" y="4206240"/>
+            <a:off x="457200" y="4251960"/>
             <a:ext cx="8229600" cy="365760"/>
           </a:xfrm>
           <a:prstGeom prst="rect">

</xml_diff>